<commit_message>
Cleaned up poster and added plots with environmental variables
</commit_message>
<xml_diff>
--- a/Poster templates/FME_COMPASS_PosterTemplate_30x40_SW.pptx
+++ b/Poster templates/FME_COMPASS_PosterTemplate_30x40_SW.pptx
@@ -10,14 +10,14 @@
   <p:sldIdLst>
     <p:sldId id="259" r:id="rId2"/>
   </p:sldIdLst>
-  <p:sldSz cx="27432000" cy="36576000"/>
+  <p:sldSz cx="36576000" cy="43891200"/>
   <p:notesSz cx="6858000" cy="9144000"/>
   <p:defaultTextStyle>
     <a:defPPr>
       <a:defRPr lang="en-US"/>
     </a:defPPr>
-    <a:lvl1pPr marL="0" algn="l" defTabSz="1567510" rtl="0" eaLnBrk="1" latinLnBrk="0" hangingPunct="1">
-      <a:defRPr sz="3100" kern="1200">
+    <a:lvl1pPr marL="0" algn="l" defTabSz="1970517" rtl="0" eaLnBrk="1" latinLnBrk="0" hangingPunct="1">
+      <a:defRPr sz="3897" kern="1200">
         <a:solidFill>
           <a:schemeClr val="tx1"/>
         </a:solidFill>
@@ -26,8 +26,8 @@
         <a:cs typeface="+mn-cs"/>
       </a:defRPr>
     </a:lvl1pPr>
-    <a:lvl2pPr marL="783755" algn="l" defTabSz="1567510" rtl="0" eaLnBrk="1" latinLnBrk="0" hangingPunct="1">
-      <a:defRPr sz="3100" kern="1200">
+    <a:lvl2pPr marL="985258" algn="l" defTabSz="1970517" rtl="0" eaLnBrk="1" latinLnBrk="0" hangingPunct="1">
+      <a:defRPr sz="3897" kern="1200">
         <a:solidFill>
           <a:schemeClr val="tx1"/>
         </a:solidFill>
@@ -36,8 +36,8 @@
         <a:cs typeface="+mn-cs"/>
       </a:defRPr>
     </a:lvl2pPr>
-    <a:lvl3pPr marL="1567510" algn="l" defTabSz="1567510" rtl="0" eaLnBrk="1" latinLnBrk="0" hangingPunct="1">
-      <a:defRPr sz="3100" kern="1200">
+    <a:lvl3pPr marL="1970517" algn="l" defTabSz="1970517" rtl="0" eaLnBrk="1" latinLnBrk="0" hangingPunct="1">
+      <a:defRPr sz="3897" kern="1200">
         <a:solidFill>
           <a:schemeClr val="tx1"/>
         </a:solidFill>
@@ -46,8 +46,8 @@
         <a:cs typeface="+mn-cs"/>
       </a:defRPr>
     </a:lvl3pPr>
-    <a:lvl4pPr marL="2351266" algn="l" defTabSz="1567510" rtl="0" eaLnBrk="1" latinLnBrk="0" hangingPunct="1">
-      <a:defRPr sz="3100" kern="1200">
+    <a:lvl4pPr marL="2955776" algn="l" defTabSz="1970517" rtl="0" eaLnBrk="1" latinLnBrk="0" hangingPunct="1">
+      <a:defRPr sz="3897" kern="1200">
         <a:solidFill>
           <a:schemeClr val="tx1"/>
         </a:solidFill>
@@ -56,8 +56,8 @@
         <a:cs typeface="+mn-cs"/>
       </a:defRPr>
     </a:lvl4pPr>
-    <a:lvl5pPr marL="3135021" algn="l" defTabSz="1567510" rtl="0" eaLnBrk="1" latinLnBrk="0" hangingPunct="1">
-      <a:defRPr sz="3100" kern="1200">
+    <a:lvl5pPr marL="3941035" algn="l" defTabSz="1970517" rtl="0" eaLnBrk="1" latinLnBrk="0" hangingPunct="1">
+      <a:defRPr sz="3897" kern="1200">
         <a:solidFill>
           <a:schemeClr val="tx1"/>
         </a:solidFill>
@@ -66,8 +66,8 @@
         <a:cs typeface="+mn-cs"/>
       </a:defRPr>
     </a:lvl5pPr>
-    <a:lvl6pPr marL="3918776" algn="l" defTabSz="1567510" rtl="0" eaLnBrk="1" latinLnBrk="0" hangingPunct="1">
-      <a:defRPr sz="3100" kern="1200">
+    <a:lvl6pPr marL="4926293" algn="l" defTabSz="1970517" rtl="0" eaLnBrk="1" latinLnBrk="0" hangingPunct="1">
+      <a:defRPr sz="3897" kern="1200">
         <a:solidFill>
           <a:schemeClr val="tx1"/>
         </a:solidFill>
@@ -76,8 +76,8 @@
         <a:cs typeface="+mn-cs"/>
       </a:defRPr>
     </a:lvl6pPr>
-    <a:lvl7pPr marL="4702531" algn="l" defTabSz="1567510" rtl="0" eaLnBrk="1" latinLnBrk="0" hangingPunct="1">
-      <a:defRPr sz="3100" kern="1200">
+    <a:lvl7pPr marL="5911552" algn="l" defTabSz="1970517" rtl="0" eaLnBrk="1" latinLnBrk="0" hangingPunct="1">
+      <a:defRPr sz="3897" kern="1200">
         <a:solidFill>
           <a:schemeClr val="tx1"/>
         </a:solidFill>
@@ -86,8 +86,8 @@
         <a:cs typeface="+mn-cs"/>
       </a:defRPr>
     </a:lvl7pPr>
-    <a:lvl8pPr marL="5486286" algn="l" defTabSz="1567510" rtl="0" eaLnBrk="1" latinLnBrk="0" hangingPunct="1">
-      <a:defRPr sz="3100" kern="1200">
+    <a:lvl8pPr marL="6896810" algn="l" defTabSz="1970517" rtl="0" eaLnBrk="1" latinLnBrk="0" hangingPunct="1">
+      <a:defRPr sz="3897" kern="1200">
         <a:solidFill>
           <a:schemeClr val="tx1"/>
         </a:solidFill>
@@ -96,8 +96,8 @@
         <a:cs typeface="+mn-cs"/>
       </a:defRPr>
     </a:lvl8pPr>
-    <a:lvl9pPr marL="6270041" algn="l" defTabSz="1567510" rtl="0" eaLnBrk="1" latinLnBrk="0" hangingPunct="1">
-      <a:defRPr sz="3100" kern="1200">
+    <a:lvl9pPr marL="7882069" algn="l" defTabSz="1970517" rtl="0" eaLnBrk="1" latinLnBrk="0" hangingPunct="1">
+      <a:defRPr sz="3897" kern="1200">
         <a:solidFill>
           <a:schemeClr val="tx1"/>
         </a:solidFill>
@@ -110,12 +110,12 @@
   <p:extLst>
     <p:ext uri="{EFAFB233-063F-42B5-8137-9DF3F51BA10A}">
       <p15:sldGuideLst xmlns:p15="http://schemas.microsoft.com/office/powerpoint/2012/main">
-        <p15:guide id="1" orient="horz" pos="11520" userDrawn="1">
+        <p15:guide id="1" orient="horz" pos="13824" userDrawn="1">
           <p15:clr>
             <a:srgbClr val="A4A3A4"/>
           </p15:clr>
         </p15:guide>
-        <p15:guide id="2" pos="8640" userDrawn="1">
+        <p15:guide id="2" pos="11520" userDrawn="1">
           <p15:clr>
             <a:srgbClr val="A4A3A4"/>
           </p15:clr>
@@ -129,9 +129,376 @@
 <file path=ppt/revisionInfo.xml><?xml version="1.0" encoding="utf-8"?>
 <p1510:revInfo xmlns:a="http://schemas.openxmlformats.org/drawingml/2006/main" xmlns:r="http://schemas.openxmlformats.org/officeDocument/2006/relationships" xmlns:p1510="http://schemas.microsoft.com/office/powerpoint/2015/10/main">
   <p1510:revLst>
-    <p1510:client id="{5E55E1C1-BB93-694E-AB97-F67020893064}" v="24" dt="2024-02-12T18:38:41.489"/>
+    <p1510:client id="{3B3307F3-40D5-416B-8F15-9E26BE3C1BE0}" v="17" dt="2026-03-12T20:24:50.072"/>
   </p1510:revLst>
 </p1510:revInfo>
+</file>
+
+<file path=ppt/changesInfos/changesInfo1.xml><?xml version="1.0" encoding="utf-8"?>
+<pc:chgInfo xmlns:a="http://schemas.openxmlformats.org/drawingml/2006/main" xmlns:r="http://schemas.openxmlformats.org/officeDocument/2006/relationships" xmlns:ac="http://schemas.microsoft.com/office/drawing/2013/main/command" xmlns:pc="http://schemas.microsoft.com/office/powerpoint/2013/main/command">
+  <pc:docChgLst>
+    <pc:chgData name="Read, Zoe" userId="b08cd0fd-26d2-470b-8ec0-c6e6cb2a79bd" providerId="ADAL" clId="{5AEB2719-95A5-4ED2-9E0E-ED462BB10526}"/>
+    <pc:docChg chg="undo custSel modSld modMainMaster">
+      <pc:chgData name="Read, Zoe" userId="b08cd0fd-26d2-470b-8ec0-c6e6cb2a79bd" providerId="ADAL" clId="{5AEB2719-95A5-4ED2-9E0E-ED462BB10526}" dt="2026-03-12T20:24:59.814" v="62" actId="478"/>
+      <pc:docMkLst>
+        <pc:docMk/>
+      </pc:docMkLst>
+      <pc:sldChg chg="addSp delSp modSp mod">
+        <pc:chgData name="Read, Zoe" userId="b08cd0fd-26d2-470b-8ec0-c6e6cb2a79bd" providerId="ADAL" clId="{5AEB2719-95A5-4ED2-9E0E-ED462BB10526}" dt="2026-03-12T20:24:59.814" v="62" actId="478"/>
+        <pc:sldMkLst>
+          <pc:docMk/>
+          <pc:sldMk cId="2004079467" sldId="259"/>
+        </pc:sldMkLst>
+        <pc:spChg chg="mod">
+          <ac:chgData name="Read, Zoe" userId="b08cd0fd-26d2-470b-8ec0-c6e6cb2a79bd" providerId="ADAL" clId="{5AEB2719-95A5-4ED2-9E0E-ED462BB10526}" dt="2026-03-12T20:18:58.981" v="1" actId="20577"/>
+          <ac:spMkLst>
+            <pc:docMk/>
+            <pc:sldMk cId="2004079467" sldId="259"/>
+            <ac:spMk id="2" creationId="{C89E8464-81CB-92D3-5AC7-A6B60763082C}"/>
+          </ac:spMkLst>
+        </pc:spChg>
+        <pc:spChg chg="mod">
+          <ac:chgData name="Read, Zoe" userId="b08cd0fd-26d2-470b-8ec0-c6e6cb2a79bd" providerId="ADAL" clId="{5AEB2719-95A5-4ED2-9E0E-ED462BB10526}" dt="2026-03-12T20:19:05.400" v="3" actId="20577"/>
+          <ac:spMkLst>
+            <pc:docMk/>
+            <pc:sldMk cId="2004079467" sldId="259"/>
+            <ac:spMk id="3" creationId="{B3465B41-DAA2-DCC9-32E9-7E00E19C28D5}"/>
+          </ac:spMkLst>
+        </pc:spChg>
+        <pc:spChg chg="mod">
+          <ac:chgData name="Read, Zoe" userId="b08cd0fd-26d2-470b-8ec0-c6e6cb2a79bd" providerId="ADAL" clId="{5AEB2719-95A5-4ED2-9E0E-ED462BB10526}" dt="2026-03-12T20:22:39.251" v="47" actId="1036"/>
+          <ac:spMkLst>
+            <pc:docMk/>
+            <pc:sldMk cId="2004079467" sldId="259"/>
+            <ac:spMk id="5" creationId="{3016F121-A2BA-A984-CB58-265698576097}"/>
+          </ac:spMkLst>
+        </pc:spChg>
+        <pc:spChg chg="del mod">
+          <ac:chgData name="Read, Zoe" userId="b08cd0fd-26d2-470b-8ec0-c6e6cb2a79bd" providerId="ADAL" clId="{5AEB2719-95A5-4ED2-9E0E-ED462BB10526}" dt="2026-03-12T20:24:59.814" v="62" actId="478"/>
+          <ac:spMkLst>
+            <pc:docMk/>
+            <pc:sldMk cId="2004079467" sldId="259"/>
+            <ac:spMk id="7" creationId="{A49C79F4-8D4A-AFB2-B2FB-211C124A5DB5}"/>
+          </ac:spMkLst>
+        </pc:spChg>
+        <pc:spChg chg="mod">
+          <ac:chgData name="Read, Zoe" userId="b08cd0fd-26d2-470b-8ec0-c6e6cb2a79bd" providerId="ADAL" clId="{5AEB2719-95A5-4ED2-9E0E-ED462BB10526}" dt="2026-03-12T20:22:30.443" v="43" actId="14100"/>
+          <ac:spMkLst>
+            <pc:docMk/>
+            <pc:sldMk cId="2004079467" sldId="259"/>
+            <ac:spMk id="9" creationId="{8E19D199-E17E-D5F1-8E33-EFB3AA0EECD3}"/>
+          </ac:spMkLst>
+        </pc:spChg>
+        <pc:spChg chg="mod">
+          <ac:chgData name="Read, Zoe" userId="b08cd0fd-26d2-470b-8ec0-c6e6cb2a79bd" providerId="ADAL" clId="{5AEB2719-95A5-4ED2-9E0E-ED462BB10526}" dt="2026-03-12T20:23:34.989" v="57" actId="1076"/>
+          <ac:spMkLst>
+            <pc:docMk/>
+            <pc:sldMk cId="2004079467" sldId="259"/>
+            <ac:spMk id="10" creationId="{36D50DBC-0E3A-0321-B973-95AEB2483598}"/>
+          </ac:spMkLst>
+        </pc:spChg>
+        <pc:spChg chg="del">
+          <ac:chgData name="Read, Zoe" userId="b08cd0fd-26d2-470b-8ec0-c6e6cb2a79bd" providerId="ADAL" clId="{5AEB2719-95A5-4ED2-9E0E-ED462BB10526}" dt="2026-03-12T20:23:38.673" v="58" actId="478"/>
+          <ac:spMkLst>
+            <pc:docMk/>
+            <pc:sldMk cId="2004079467" sldId="259"/>
+            <ac:spMk id="11" creationId="{CC70C158-B8B1-73B0-0C7A-54B956AEA3BB}"/>
+          </ac:spMkLst>
+        </pc:spChg>
+        <pc:spChg chg="mod">
+          <ac:chgData name="Read, Zoe" userId="b08cd0fd-26d2-470b-8ec0-c6e6cb2a79bd" providerId="ADAL" clId="{5AEB2719-95A5-4ED2-9E0E-ED462BB10526}" dt="2026-03-12T20:22:39.251" v="47" actId="1036"/>
+          <ac:spMkLst>
+            <pc:docMk/>
+            <pc:sldMk cId="2004079467" sldId="259"/>
+            <ac:spMk id="16" creationId="{E0D9E24C-C2DB-2D0E-CA54-54F25AC8CC0A}"/>
+          </ac:spMkLst>
+        </pc:spChg>
+        <pc:spChg chg="mod">
+          <ac:chgData name="Read, Zoe" userId="b08cd0fd-26d2-470b-8ec0-c6e6cb2a79bd" providerId="ADAL" clId="{5AEB2719-95A5-4ED2-9E0E-ED462BB10526}" dt="2026-03-12T20:22:39.251" v="47" actId="1036"/>
+          <ac:spMkLst>
+            <pc:docMk/>
+            <pc:sldMk cId="2004079467" sldId="259"/>
+            <ac:spMk id="18" creationId="{920C9DEA-E578-5373-18E5-350865C7777A}"/>
+          </ac:spMkLst>
+        </pc:spChg>
+        <pc:spChg chg="mod">
+          <ac:chgData name="Read, Zoe" userId="b08cd0fd-26d2-470b-8ec0-c6e6cb2a79bd" providerId="ADAL" clId="{5AEB2719-95A5-4ED2-9E0E-ED462BB10526}" dt="2026-03-12T20:22:39.251" v="47" actId="1036"/>
+          <ac:spMkLst>
+            <pc:docMk/>
+            <pc:sldMk cId="2004079467" sldId="259"/>
+            <ac:spMk id="22" creationId="{F9695197-0372-36BD-CF7D-7C6BADCA7DB9}"/>
+          </ac:spMkLst>
+        </pc:spChg>
+        <pc:spChg chg="mod">
+          <ac:chgData name="Read, Zoe" userId="b08cd0fd-26d2-470b-8ec0-c6e6cb2a79bd" providerId="ADAL" clId="{5AEB2719-95A5-4ED2-9E0E-ED462BB10526}" dt="2026-03-12T20:22:39.251" v="47" actId="1036"/>
+          <ac:spMkLst>
+            <pc:docMk/>
+            <pc:sldMk cId="2004079467" sldId="259"/>
+            <ac:spMk id="23" creationId="{ABA8B7CC-1FE4-251F-79DA-0A05B8700085}"/>
+          </ac:spMkLst>
+        </pc:spChg>
+        <pc:spChg chg="mod">
+          <ac:chgData name="Read, Zoe" userId="b08cd0fd-26d2-470b-8ec0-c6e6cb2a79bd" providerId="ADAL" clId="{5AEB2719-95A5-4ED2-9E0E-ED462BB10526}" dt="2026-03-12T20:22:39.251" v="47" actId="1036"/>
+          <ac:spMkLst>
+            <pc:docMk/>
+            <pc:sldMk cId="2004079467" sldId="259"/>
+            <ac:spMk id="25" creationId="{4C5B3312-2479-3346-1E6F-62ED14C1564E}"/>
+          </ac:spMkLst>
+        </pc:spChg>
+        <pc:spChg chg="mod">
+          <ac:chgData name="Read, Zoe" userId="b08cd0fd-26d2-470b-8ec0-c6e6cb2a79bd" providerId="ADAL" clId="{5AEB2719-95A5-4ED2-9E0E-ED462BB10526}" dt="2026-03-12T20:22:39.251" v="47" actId="1036"/>
+          <ac:spMkLst>
+            <pc:docMk/>
+            <pc:sldMk cId="2004079467" sldId="259"/>
+            <ac:spMk id="26" creationId="{51528697-AA68-29FF-9215-D838167DF3EF}"/>
+          </ac:spMkLst>
+        </pc:spChg>
+        <pc:spChg chg="mod">
+          <ac:chgData name="Read, Zoe" userId="b08cd0fd-26d2-470b-8ec0-c6e6cb2a79bd" providerId="ADAL" clId="{5AEB2719-95A5-4ED2-9E0E-ED462BB10526}" dt="2026-03-12T20:22:39.251" v="47" actId="1036"/>
+          <ac:spMkLst>
+            <pc:docMk/>
+            <pc:sldMk cId="2004079467" sldId="259"/>
+            <ac:spMk id="27" creationId="{7B372F78-9019-1A74-3F3C-916FFA4FFDC1}"/>
+          </ac:spMkLst>
+        </pc:spChg>
+        <pc:spChg chg="mod">
+          <ac:chgData name="Read, Zoe" userId="b08cd0fd-26d2-470b-8ec0-c6e6cb2a79bd" providerId="ADAL" clId="{5AEB2719-95A5-4ED2-9E0E-ED462BB10526}" dt="2026-03-12T20:22:39.251" v="47" actId="1036"/>
+          <ac:spMkLst>
+            <pc:docMk/>
+            <pc:sldMk cId="2004079467" sldId="259"/>
+            <ac:spMk id="28" creationId="{BFE2514F-65F7-C634-5697-EA483C6F84BF}"/>
+          </ac:spMkLst>
+        </pc:spChg>
+        <pc:spChg chg="mod">
+          <ac:chgData name="Read, Zoe" userId="b08cd0fd-26d2-470b-8ec0-c6e6cb2a79bd" providerId="ADAL" clId="{5AEB2719-95A5-4ED2-9E0E-ED462BB10526}" dt="2026-03-12T20:22:39.251" v="47" actId="1036"/>
+          <ac:spMkLst>
+            <pc:docMk/>
+            <pc:sldMk cId="2004079467" sldId="259"/>
+            <ac:spMk id="29" creationId="{C32DDAA2-6DBA-FC18-4A38-004EDC74ED07}"/>
+          </ac:spMkLst>
+        </pc:spChg>
+        <pc:spChg chg="add mod">
+          <ac:chgData name="Read, Zoe" userId="b08cd0fd-26d2-470b-8ec0-c6e6cb2a79bd" providerId="ADAL" clId="{5AEB2719-95A5-4ED2-9E0E-ED462BB10526}" dt="2026-03-12T20:23:48.248" v="60" actId="14100"/>
+          <ac:spMkLst>
+            <pc:docMk/>
+            <pc:sldMk cId="2004079467" sldId="259"/>
+            <ac:spMk id="31" creationId="{EBEF1B36-51E3-0CF2-F9CF-8EAE0D3881FF}"/>
+          </ac:spMkLst>
+        </pc:spChg>
+        <pc:graphicFrameChg chg="mod">
+          <ac:chgData name="Read, Zoe" userId="b08cd0fd-26d2-470b-8ec0-c6e6cb2a79bd" providerId="ADAL" clId="{5AEB2719-95A5-4ED2-9E0E-ED462BB10526}" dt="2026-03-12T20:22:35.332" v="44" actId="1076"/>
+          <ac:graphicFrameMkLst>
+            <pc:docMk/>
+            <pc:sldMk cId="2004079467" sldId="259"/>
+            <ac:graphicFrameMk id="14" creationId="{56F9B1C2-D9C1-75DA-BFAC-38CC49A9F9DC}"/>
+          </ac:graphicFrameMkLst>
+        </pc:graphicFrameChg>
+        <pc:picChg chg="add mod">
+          <ac:chgData name="Read, Zoe" userId="b08cd0fd-26d2-470b-8ec0-c6e6cb2a79bd" providerId="ADAL" clId="{5AEB2719-95A5-4ED2-9E0E-ED462BB10526}" dt="2026-03-12T20:23:02.190" v="49" actId="1076"/>
+          <ac:picMkLst>
+            <pc:docMk/>
+            <pc:sldMk cId="2004079467" sldId="259"/>
+            <ac:picMk id="30" creationId="{E49A93CD-9A22-A9D8-A4F9-ABBFD8A3A429}"/>
+          </ac:picMkLst>
+        </pc:picChg>
+        <pc:picChg chg="add mod">
+          <ac:chgData name="Read, Zoe" userId="b08cd0fd-26d2-470b-8ec0-c6e6cb2a79bd" providerId="ADAL" clId="{5AEB2719-95A5-4ED2-9E0E-ED462BB10526}" dt="2026-03-12T20:23:52.336" v="61" actId="1076"/>
+          <ac:picMkLst>
+            <pc:docMk/>
+            <pc:sldMk cId="2004079467" sldId="259"/>
+            <ac:picMk id="32" creationId="{98B7A699-3802-B555-5777-71C8B25EFD4A}"/>
+          </ac:picMkLst>
+        </pc:picChg>
+      </pc:sldChg>
+      <pc:sldMasterChg chg="modSldLayout">
+        <pc:chgData name="Read, Zoe" userId="b08cd0fd-26d2-470b-8ec0-c6e6cb2a79bd" providerId="ADAL" clId="{5AEB2719-95A5-4ED2-9E0E-ED462BB10526}" dt="2026-03-12T20:21:30.489" v="32" actId="20577"/>
+        <pc:sldMasterMkLst>
+          <pc:docMk/>
+          <pc:sldMasterMk cId="3968463654" sldId="2147483648"/>
+        </pc:sldMasterMkLst>
+        <pc:sldLayoutChg chg="delSp modSp mod">
+          <pc:chgData name="Read, Zoe" userId="b08cd0fd-26d2-470b-8ec0-c6e6cb2a79bd" providerId="ADAL" clId="{5AEB2719-95A5-4ED2-9E0E-ED462BB10526}" dt="2026-03-12T20:21:30.489" v="32" actId="20577"/>
+          <pc:sldLayoutMkLst>
+            <pc:docMk/>
+            <pc:sldMasterMk cId="3968463654" sldId="2147483648"/>
+            <pc:sldLayoutMk cId="2303059013" sldId="2147483649"/>
+          </pc:sldLayoutMkLst>
+          <pc:spChg chg="mod">
+            <ac:chgData name="Read, Zoe" userId="b08cd0fd-26d2-470b-8ec0-c6e6cb2a79bd" providerId="ADAL" clId="{5AEB2719-95A5-4ED2-9E0E-ED462BB10526}" dt="2026-03-12T20:21:30.489" v="32" actId="20577"/>
+            <ac:spMkLst>
+              <pc:docMk/>
+              <pc:sldMasterMk cId="3968463654" sldId="2147483648"/>
+              <pc:sldLayoutMk cId="2303059013" sldId="2147483649"/>
+              <ac:spMk id="4" creationId="{03672AAF-4B6B-9046-B08E-E3EDCC2CB619}"/>
+            </ac:spMkLst>
+          </pc:spChg>
+          <pc:spChg chg="mod">
+            <ac:chgData name="Read, Zoe" userId="b08cd0fd-26d2-470b-8ec0-c6e6cb2a79bd" providerId="ADAL" clId="{5AEB2719-95A5-4ED2-9E0E-ED462BB10526}" dt="2026-03-12T20:21:03.670" v="19" actId="1076"/>
+            <ac:spMkLst>
+              <pc:docMk/>
+              <pc:sldMasterMk cId="3968463654" sldId="2147483648"/>
+              <pc:sldLayoutMk cId="2303059013" sldId="2147483649"/>
+              <ac:spMk id="6" creationId="{68F935FF-E10C-FFC5-69DA-C2A6123D4762}"/>
+            </ac:spMkLst>
+          </pc:spChg>
+          <pc:spChg chg="mod">
+            <ac:chgData name="Read, Zoe" userId="b08cd0fd-26d2-470b-8ec0-c6e6cb2a79bd" providerId="ADAL" clId="{5AEB2719-95A5-4ED2-9E0E-ED462BB10526}" dt="2026-03-12T20:21:26.497" v="31" actId="20577"/>
+            <ac:spMkLst>
+              <pc:docMk/>
+              <pc:sldMasterMk cId="3968463654" sldId="2147483648"/>
+              <pc:sldLayoutMk cId="2303059013" sldId="2147483649"/>
+              <ac:spMk id="7" creationId="{D5658E99-2B7E-A94A-AE07-8B6946534EF5}"/>
+            </ac:spMkLst>
+          </pc:spChg>
+          <pc:spChg chg="mod">
+            <ac:chgData name="Read, Zoe" userId="b08cd0fd-26d2-470b-8ec0-c6e6cb2a79bd" providerId="ADAL" clId="{5AEB2719-95A5-4ED2-9E0E-ED462BB10526}" dt="2026-03-12T20:19:56.820" v="8" actId="14100"/>
+            <ac:spMkLst>
+              <pc:docMk/>
+              <pc:sldMasterMk cId="3968463654" sldId="2147483648"/>
+              <pc:sldLayoutMk cId="2303059013" sldId="2147483649"/>
+              <ac:spMk id="13" creationId="{CBC0CC5A-BCC7-7A40-B8AC-3C8CB9773C97}"/>
+            </ac:spMkLst>
+          </pc:spChg>
+          <pc:spChg chg="mod">
+            <ac:chgData name="Read, Zoe" userId="b08cd0fd-26d2-470b-8ec0-c6e6cb2a79bd" providerId="ADAL" clId="{5AEB2719-95A5-4ED2-9E0E-ED462BB10526}" dt="2026-03-12T20:21:18.671" v="29" actId="14100"/>
+            <ac:spMkLst>
+              <pc:docMk/>
+              <pc:sldMasterMk cId="3968463654" sldId="2147483648"/>
+              <pc:sldLayoutMk cId="2303059013" sldId="2147483649"/>
+              <ac:spMk id="15" creationId="{01A52ABB-BD90-CAC1-C869-D7B6CFD31FDA}"/>
+            </ac:spMkLst>
+          </pc:spChg>
+          <pc:spChg chg="del">
+            <ac:chgData name="Read, Zoe" userId="b08cd0fd-26d2-470b-8ec0-c6e6cb2a79bd" providerId="ADAL" clId="{5AEB2719-95A5-4ED2-9E0E-ED462BB10526}" dt="2026-03-12T20:21:11.580" v="25" actId="478"/>
+            <ac:spMkLst>
+              <pc:docMk/>
+              <pc:sldMasterMk cId="3968463654" sldId="2147483648"/>
+              <pc:sldLayoutMk cId="2303059013" sldId="2147483649"/>
+              <ac:spMk id="16" creationId="{3598C78C-3D1C-E7D5-81A3-C84A617ED994}"/>
+            </ac:spMkLst>
+          </pc:spChg>
+          <pc:spChg chg="del mod">
+            <ac:chgData name="Read, Zoe" userId="b08cd0fd-26d2-470b-8ec0-c6e6cb2a79bd" providerId="ADAL" clId="{5AEB2719-95A5-4ED2-9E0E-ED462BB10526}" dt="2026-03-12T20:21:07.309" v="23"/>
+            <ac:spMkLst>
+              <pc:docMk/>
+              <pc:sldMasterMk cId="3968463654" sldId="2147483648"/>
+              <pc:sldLayoutMk cId="2303059013" sldId="2147483649"/>
+              <ac:spMk id="17" creationId="{2C0A0260-FD8F-5425-24CC-3D54BD120A1D}"/>
+            </ac:spMkLst>
+          </pc:spChg>
+          <pc:spChg chg="del">
+            <ac:chgData name="Read, Zoe" userId="b08cd0fd-26d2-470b-8ec0-c6e6cb2a79bd" providerId="ADAL" clId="{5AEB2719-95A5-4ED2-9E0E-ED462BB10526}" dt="2026-03-12T20:20:55.270" v="15" actId="478"/>
+            <ac:spMkLst>
+              <pc:docMk/>
+              <pc:sldMasterMk cId="3968463654" sldId="2147483648"/>
+              <pc:sldLayoutMk cId="2303059013" sldId="2147483649"/>
+              <ac:spMk id="18" creationId="{B3EFDF2F-6EC7-FE8C-EDAA-E8D55397FA64}"/>
+            </ac:spMkLst>
+          </pc:spChg>
+          <pc:spChg chg="mod">
+            <ac:chgData name="Read, Zoe" userId="b08cd0fd-26d2-470b-8ec0-c6e6cb2a79bd" providerId="ADAL" clId="{5AEB2719-95A5-4ED2-9E0E-ED462BB10526}" dt="2026-03-12T20:21:09.286" v="24" actId="20577"/>
+            <ac:spMkLst>
+              <pc:docMk/>
+              <pc:sldMasterMk cId="3968463654" sldId="2147483648"/>
+              <pc:sldLayoutMk cId="2303059013" sldId="2147483649"/>
+              <ac:spMk id="35" creationId="{3507BECC-C81A-C7FF-38FF-A990C25D7707}"/>
+            </ac:spMkLst>
+          </pc:spChg>
+          <pc:spChg chg="mod">
+            <ac:chgData name="Read, Zoe" userId="b08cd0fd-26d2-470b-8ec0-c6e6cb2a79bd" providerId="ADAL" clId="{5AEB2719-95A5-4ED2-9E0E-ED462BB10526}" dt="2026-03-12T20:20:52.709" v="13" actId="6549"/>
+            <ac:spMkLst>
+              <pc:docMk/>
+              <pc:sldMasterMk cId="3968463654" sldId="2147483648"/>
+              <pc:sldLayoutMk cId="2303059013" sldId="2147483649"/>
+              <ac:spMk id="36" creationId="{5505AF57-180B-952E-D778-2D4468FD79A8}"/>
+            </ac:spMkLst>
+          </pc:spChg>
+          <pc:spChg chg="mod">
+            <ac:chgData name="Read, Zoe" userId="b08cd0fd-26d2-470b-8ec0-c6e6cb2a79bd" providerId="ADAL" clId="{5AEB2719-95A5-4ED2-9E0E-ED462BB10526}" dt="2026-03-12T20:21:14.441" v="26" actId="20577"/>
+            <ac:spMkLst>
+              <pc:docMk/>
+              <pc:sldMasterMk cId="3968463654" sldId="2147483648"/>
+              <pc:sldLayoutMk cId="2303059013" sldId="2147483649"/>
+              <ac:spMk id="37" creationId="{6C3E73A2-68E7-4E25-CC87-680F195E64F6}"/>
+            </ac:spMkLst>
+          </pc:spChg>
+          <pc:picChg chg="del">
+            <ac:chgData name="Read, Zoe" userId="b08cd0fd-26d2-470b-8ec0-c6e6cb2a79bd" providerId="ADAL" clId="{5AEB2719-95A5-4ED2-9E0E-ED462BB10526}" dt="2026-03-12T20:21:07.309" v="21" actId="478"/>
+            <ac:picMkLst>
+              <pc:docMk/>
+              <pc:sldMasterMk cId="3968463654" sldId="2147483648"/>
+              <pc:sldLayoutMk cId="2303059013" sldId="2147483649"/>
+              <ac:picMk id="8" creationId="{8C23AF20-6302-6F05-533A-18008226ABDE}"/>
+            </ac:picMkLst>
+          </pc:picChg>
+          <pc:picChg chg="del">
+            <ac:chgData name="Read, Zoe" userId="b08cd0fd-26d2-470b-8ec0-c6e6cb2a79bd" providerId="ADAL" clId="{5AEB2719-95A5-4ED2-9E0E-ED462BB10526}" dt="2026-03-12T20:20:56.460" v="16" actId="478"/>
+            <ac:picMkLst>
+              <pc:docMk/>
+              <pc:sldMasterMk cId="3968463654" sldId="2147483648"/>
+              <pc:sldLayoutMk cId="2303059013" sldId="2147483649"/>
+              <ac:picMk id="9" creationId="{F612A36F-93E9-7EED-6722-54D07738DDD6}"/>
+            </ac:picMkLst>
+          </pc:picChg>
+          <pc:picChg chg="del">
+            <ac:chgData name="Read, Zoe" userId="b08cd0fd-26d2-470b-8ec0-c6e6cb2a79bd" providerId="ADAL" clId="{5AEB2719-95A5-4ED2-9E0E-ED462BB10526}" dt="2026-03-12T20:21:15.237" v="28" actId="478"/>
+            <ac:picMkLst>
+              <pc:docMk/>
+              <pc:sldMasterMk cId="3968463654" sldId="2147483648"/>
+              <pc:sldLayoutMk cId="2303059013" sldId="2147483649"/>
+              <ac:picMk id="10" creationId="{F97BFD72-95EA-B95D-4E34-C555984AA9CF}"/>
+            </ac:picMkLst>
+          </pc:picChg>
+          <pc:picChg chg="del">
+            <ac:chgData name="Read, Zoe" userId="b08cd0fd-26d2-470b-8ec0-c6e6cb2a79bd" providerId="ADAL" clId="{5AEB2719-95A5-4ED2-9E0E-ED462BB10526}" dt="2026-03-12T20:21:14.836" v="27" actId="478"/>
+            <ac:picMkLst>
+              <pc:docMk/>
+              <pc:sldMasterMk cId="3968463654" sldId="2147483648"/>
+              <pc:sldLayoutMk cId="2303059013" sldId="2147483649"/>
+              <ac:picMk id="11" creationId="{9556A4D9-E30B-7880-F8D4-F58E8DB18628}"/>
+            </ac:picMkLst>
+          </pc:picChg>
+          <pc:picChg chg="del">
+            <ac:chgData name="Read, Zoe" userId="b08cd0fd-26d2-470b-8ec0-c6e6cb2a79bd" providerId="ADAL" clId="{5AEB2719-95A5-4ED2-9E0E-ED462BB10526}" dt="2026-03-12T20:20:53.395" v="14" actId="478"/>
+            <ac:picMkLst>
+              <pc:docMk/>
+              <pc:sldMasterMk cId="3968463654" sldId="2147483648"/>
+              <pc:sldLayoutMk cId="2303059013" sldId="2147483649"/>
+              <ac:picMk id="12" creationId="{600DBE1F-DBA4-432F-2CE7-9A02370754F0}"/>
+            </ac:picMkLst>
+          </pc:picChg>
+          <pc:picChg chg="del">
+            <ac:chgData name="Read, Zoe" userId="b08cd0fd-26d2-470b-8ec0-c6e6cb2a79bd" providerId="ADAL" clId="{5AEB2719-95A5-4ED2-9E0E-ED462BB10526}" dt="2026-03-12T20:20:07.572" v="11" actId="478"/>
+            <ac:picMkLst>
+              <pc:docMk/>
+              <pc:sldMasterMk cId="3968463654" sldId="2147483648"/>
+              <pc:sldLayoutMk cId="2303059013" sldId="2147483649"/>
+              <ac:picMk id="14" creationId="{8CB6B30F-8038-D6CE-F940-82651B090D45}"/>
+            </ac:picMkLst>
+          </pc:picChg>
+          <pc:picChg chg="del">
+            <ac:chgData name="Read, Zoe" userId="b08cd0fd-26d2-470b-8ec0-c6e6cb2a79bd" providerId="ADAL" clId="{5AEB2719-95A5-4ED2-9E0E-ED462BB10526}" dt="2026-03-12T20:19:51.041" v="7" actId="478"/>
+            <ac:picMkLst>
+              <pc:docMk/>
+              <pc:sldMasterMk cId="3968463654" sldId="2147483648"/>
+              <pc:sldLayoutMk cId="2303059013" sldId="2147483649"/>
+              <ac:picMk id="1026" creationId="{E3DAD434-E52C-21EF-CF89-8E5DB79F9485}"/>
+            </ac:picMkLst>
+          </pc:picChg>
+          <pc:picChg chg="del">
+            <ac:chgData name="Read, Zoe" userId="b08cd0fd-26d2-470b-8ec0-c6e6cb2a79bd" providerId="ADAL" clId="{5AEB2719-95A5-4ED2-9E0E-ED462BB10526}" dt="2026-03-12T20:20:05.192" v="10" actId="478"/>
+            <ac:picMkLst>
+              <pc:docMk/>
+              <pc:sldMasterMk cId="3968463654" sldId="2147483648"/>
+              <pc:sldLayoutMk cId="2303059013" sldId="2147483649"/>
+              <ac:picMk id="1028" creationId="{7D448C49-0C1B-E954-193D-E55443DB7E4D}"/>
+            </ac:picMkLst>
+          </pc:picChg>
+        </pc:sldLayoutChg>
+      </pc:sldMasterChg>
+    </pc:docChg>
+  </pc:docChgLst>
+</pc:chgInfo>
 </file>
 
 <file path=ppt/notesMasters/notesMaster1.xml><?xml version="1.0" encoding="utf-8"?>
@@ -216,7 +583,7 @@
           <a:p>
             <a:fld id="{0407BD97-90D8-3541-9414-B17D17D02539}" type="datetimeFigureOut">
               <a:rPr lang="en-US" smtClean="0"/>
-              <a:t>3/28/2024</a:t>
+              <a:t>3/12/2026</a:t>
             </a:fld>
             <a:endParaRPr lang="en-US"/>
           </a:p>
@@ -234,8 +601,8 @@
         </p:nvSpPr>
         <p:spPr>
           <a:xfrm>
-            <a:off x="2143125" y="685800"/>
-            <a:ext cx="2571750" cy="3429000"/>
+            <a:off x="2000250" y="685800"/>
+            <a:ext cx="2857500" cy="3429000"/>
           </a:xfrm>
           <a:prstGeom prst="rect">
             <a:avLst/>
@@ -389,8 +756,8 @@
   </p:cSld>
   <p:clrMap bg1="lt1" tx1="dk1" bg2="lt2" tx2="dk2" accent1="accent1" accent2="accent2" accent3="accent3" accent4="accent4" accent5="accent5" accent6="accent6" hlink="hlink" folHlink="folHlink"/>
   <p:notesStyle>
-    <a:lvl1pPr marL="0" algn="l" defTabSz="457200" rtl="0" eaLnBrk="1" latinLnBrk="0" hangingPunct="1">
-      <a:defRPr sz="1200" kern="1200">
+    <a:lvl1pPr marL="0" algn="l" defTabSz="574746" rtl="0" eaLnBrk="1" latinLnBrk="0" hangingPunct="1">
+      <a:defRPr sz="1509" kern="1200">
         <a:solidFill>
           <a:schemeClr val="tx1"/>
         </a:solidFill>
@@ -399,8 +766,8 @@
         <a:cs typeface="+mn-cs"/>
       </a:defRPr>
     </a:lvl1pPr>
-    <a:lvl2pPr marL="457200" algn="l" defTabSz="457200" rtl="0" eaLnBrk="1" latinLnBrk="0" hangingPunct="1">
-      <a:defRPr sz="1200" kern="1200">
+    <a:lvl2pPr marL="574746" algn="l" defTabSz="574746" rtl="0" eaLnBrk="1" latinLnBrk="0" hangingPunct="1">
+      <a:defRPr sz="1509" kern="1200">
         <a:solidFill>
           <a:schemeClr val="tx1"/>
         </a:solidFill>
@@ -409,8 +776,8 @@
         <a:cs typeface="+mn-cs"/>
       </a:defRPr>
     </a:lvl2pPr>
-    <a:lvl3pPr marL="914400" algn="l" defTabSz="457200" rtl="0" eaLnBrk="1" latinLnBrk="0" hangingPunct="1">
-      <a:defRPr sz="1200" kern="1200">
+    <a:lvl3pPr marL="1149492" algn="l" defTabSz="574746" rtl="0" eaLnBrk="1" latinLnBrk="0" hangingPunct="1">
+      <a:defRPr sz="1509" kern="1200">
         <a:solidFill>
           <a:schemeClr val="tx1"/>
         </a:solidFill>
@@ -419,8 +786,8 @@
         <a:cs typeface="+mn-cs"/>
       </a:defRPr>
     </a:lvl3pPr>
-    <a:lvl4pPr marL="1371600" algn="l" defTabSz="457200" rtl="0" eaLnBrk="1" latinLnBrk="0" hangingPunct="1">
-      <a:defRPr sz="1200" kern="1200">
+    <a:lvl4pPr marL="1724238" algn="l" defTabSz="574746" rtl="0" eaLnBrk="1" latinLnBrk="0" hangingPunct="1">
+      <a:defRPr sz="1509" kern="1200">
         <a:solidFill>
           <a:schemeClr val="tx1"/>
         </a:solidFill>
@@ -429,8 +796,8 @@
         <a:cs typeface="+mn-cs"/>
       </a:defRPr>
     </a:lvl4pPr>
-    <a:lvl5pPr marL="1828800" algn="l" defTabSz="457200" rtl="0" eaLnBrk="1" latinLnBrk="0" hangingPunct="1">
-      <a:defRPr sz="1200" kern="1200">
+    <a:lvl5pPr marL="2298984" algn="l" defTabSz="574746" rtl="0" eaLnBrk="1" latinLnBrk="0" hangingPunct="1">
+      <a:defRPr sz="1509" kern="1200">
         <a:solidFill>
           <a:schemeClr val="tx1"/>
         </a:solidFill>
@@ -439,8 +806,8 @@
         <a:cs typeface="+mn-cs"/>
       </a:defRPr>
     </a:lvl5pPr>
-    <a:lvl6pPr marL="2286000" algn="l" defTabSz="457200" rtl="0" eaLnBrk="1" latinLnBrk="0" hangingPunct="1">
-      <a:defRPr sz="1200" kern="1200">
+    <a:lvl6pPr marL="2873731" algn="l" defTabSz="574746" rtl="0" eaLnBrk="1" latinLnBrk="0" hangingPunct="1">
+      <a:defRPr sz="1509" kern="1200">
         <a:solidFill>
           <a:schemeClr val="tx1"/>
         </a:solidFill>
@@ -449,8 +816,8 @@
         <a:cs typeface="+mn-cs"/>
       </a:defRPr>
     </a:lvl6pPr>
-    <a:lvl7pPr marL="2743200" algn="l" defTabSz="457200" rtl="0" eaLnBrk="1" latinLnBrk="0" hangingPunct="1">
-      <a:defRPr sz="1200" kern="1200">
+    <a:lvl7pPr marL="3448477" algn="l" defTabSz="574746" rtl="0" eaLnBrk="1" latinLnBrk="0" hangingPunct="1">
+      <a:defRPr sz="1509" kern="1200">
         <a:solidFill>
           <a:schemeClr val="tx1"/>
         </a:solidFill>
@@ -459,8 +826,8 @@
         <a:cs typeface="+mn-cs"/>
       </a:defRPr>
     </a:lvl7pPr>
-    <a:lvl8pPr marL="3200400" algn="l" defTabSz="457200" rtl="0" eaLnBrk="1" latinLnBrk="0" hangingPunct="1">
-      <a:defRPr sz="1200" kern="1200">
+    <a:lvl8pPr marL="4023223" algn="l" defTabSz="574746" rtl="0" eaLnBrk="1" latinLnBrk="0" hangingPunct="1">
+      <a:defRPr sz="1509" kern="1200">
         <a:solidFill>
           <a:schemeClr val="tx1"/>
         </a:solidFill>
@@ -469,8 +836,8 @@
         <a:cs typeface="+mn-cs"/>
       </a:defRPr>
     </a:lvl8pPr>
-    <a:lvl9pPr marL="3657600" algn="l" defTabSz="457200" rtl="0" eaLnBrk="1" latinLnBrk="0" hangingPunct="1">
-      <a:defRPr sz="1200" kern="1200">
+    <a:lvl9pPr marL="4597969" algn="l" defTabSz="574746" rtl="0" eaLnBrk="1" latinLnBrk="0" hangingPunct="1">
+      <a:defRPr sz="1509" kern="1200">
         <a:solidFill>
           <a:schemeClr val="tx1"/>
         </a:solidFill>
@@ -512,8 +879,8 @@
         </p:nvSpPr>
         <p:spPr>
           <a:xfrm>
-            <a:off x="2143125" y="685800"/>
-            <a:ext cx="2571750" cy="3429000"/>
+            <a:off x="2000250" y="685800"/>
+            <a:ext cx="2857500" cy="3429000"/>
           </a:xfrm>
         </p:spPr>
       </p:sp>
@@ -631,13 +998,13 @@
             <a:spLocks noGrp="1"/>
           </p:cNvSpPr>
           <p:nvPr>
-            <p:ph type="title" hasCustomPrompt="1"/>
+            <p:ph type="title"/>
           </p:nvPr>
         </p:nvSpPr>
         <p:spPr>
           <a:xfrm>
-            <a:off x="1049722" y="1130300"/>
-            <a:ext cx="25603200" cy="1951820"/>
+            <a:off x="1399629" y="1356360"/>
+            <a:ext cx="34137600" cy="2342184"/>
           </a:xfrm>
           <a:prstGeom prst="rect">
             <a:avLst/>
@@ -649,14 +1016,11 @@
           </a:bodyPr>
           <a:lstStyle>
             <a:lvl1pPr>
-              <a:defRPr sz="5400" b="1"/>
+              <a:defRPr sz="6480" b="1"/>
             </a:lvl1pPr>
           </a:lstStyle>
           <a:p>
-            <a:r>
-              <a:rPr lang="en-US" dirty="0"/>
-              <a:t>Biogeochemistry and Function across the Terrestrial-Aquatic Interface: Transition Zones Present Unique and Non-Conservative Behavior</a:t>
-            </a:r>
+            <a:endParaRPr lang="en-US" dirty="0"/>
           </a:p>
         </p:txBody>
       </p:sp>
@@ -673,13 +1037,13 @@
             <a:spLocks noGrp="1"/>
           </p:cNvSpPr>
           <p:nvPr>
-            <p:ph type="body" sz="quarter" idx="10" hasCustomPrompt="1"/>
+            <p:ph type="body" sz="quarter" idx="10"/>
           </p:nvPr>
         </p:nvSpPr>
         <p:spPr>
           <a:xfrm>
-            <a:off x="1049721" y="3282436"/>
-            <a:ext cx="25593479" cy="1365764"/>
+            <a:off x="1399629" y="3938923"/>
+            <a:ext cx="34124639" cy="1638917"/>
           </a:xfrm>
           <a:prstGeom prst="rect">
             <a:avLst/>
@@ -689,111 +1053,13 @@
           <a:bodyPr/>
           <a:lstStyle>
             <a:lvl1pPr>
-              <a:defRPr sz="2200">
+              <a:defRPr sz="2640">
                 <a:latin typeface="+mn-lt"/>
               </a:defRPr>
             </a:lvl1pPr>
           </a:lstStyle>
           <a:p>
             <a:pPr lvl="0"/>
-            <a:r>
-              <a:rPr lang="en-US" dirty="0"/>
-              <a:t>Stephanie J. Wilson1*, Patrick Megonigal1, Fausto Machado-Silva2, Roberta Bittencourt Peixoto2, Matthew Kovach2, Leticia Sandoval2, Roy Rich1, Alice Stearns1, Evan Phillips1, Peter Regier3, Allison Myers-Pigg3, Stephanie Pennington3, Anya Hopple1, Kendalynn A. Morris3, Nate McDowell3, Ben Bond-Lamberty3, Mike Weintraub2, Nick Ward3, Ken Kemner4, and Vanessa Bailey3</a:t>
-            </a:r>
-          </a:p>
-          <a:p>
-            <a:pPr lvl="0"/>
-            <a:endParaRPr lang="en-US" dirty="0"/>
-          </a:p>
-          <a:p>
-            <a:pPr rtl="0">
-              <a:spcBef>
-                <a:spcPts val="0"/>
-              </a:spcBef>
-              <a:spcAft>
-                <a:spcPts val="0"/>
-              </a:spcAft>
-            </a:pPr>
-            <a:r>
-              <a:rPr lang="en-US" sz="1800" b="0" i="0" u="none" strike="noStrike" baseline="30000" dirty="0">
-                <a:solidFill>
-                  <a:srgbClr val="000000"/>
-                </a:solidFill>
-                <a:effectLst/>
-                <a:latin typeface="Times New Roman" panose="02020603050405020304" pitchFamily="18" charset="0"/>
-              </a:rPr>
-              <a:t>1</a:t>
-            </a:r>
-            <a:r>
-              <a:rPr lang="en-US" sz="1800" b="0" i="0" u="none" strike="noStrike" dirty="0">
-                <a:solidFill>
-                  <a:srgbClr val="000000"/>
-                </a:solidFill>
-                <a:effectLst/>
-                <a:latin typeface="Times New Roman" panose="02020603050405020304" pitchFamily="18" charset="0"/>
-              </a:rPr>
-              <a:t>Smithsonian Environmental Research Center, Edgewater, MD; </a:t>
-            </a:r>
-            <a:r>
-              <a:rPr lang="en-US" sz="1800" b="0" i="0" u="none" strike="noStrike" baseline="30000" dirty="0">
-                <a:solidFill>
-                  <a:srgbClr val="000000"/>
-                </a:solidFill>
-                <a:effectLst/>
-                <a:latin typeface="Times New Roman" panose="02020603050405020304" pitchFamily="18" charset="0"/>
-              </a:rPr>
-              <a:t>2</a:t>
-            </a:r>
-            <a:r>
-              <a:rPr lang="en-US" sz="1800" b="0" i="0" u="none" strike="noStrike" dirty="0">
-                <a:solidFill>
-                  <a:srgbClr val="000000"/>
-                </a:solidFill>
-                <a:effectLst/>
-                <a:latin typeface="Times New Roman" panose="02020603050405020304" pitchFamily="18" charset="0"/>
-              </a:rPr>
-              <a:t>University of Toledo, Toledo, OH, USA; </a:t>
-            </a:r>
-            <a:r>
-              <a:rPr lang="en-US" sz="1800" b="0" i="0" u="none" strike="noStrike" baseline="30000" dirty="0">
-                <a:solidFill>
-                  <a:srgbClr val="000000"/>
-                </a:solidFill>
-                <a:effectLst/>
-                <a:latin typeface="Times New Roman" panose="02020603050405020304" pitchFamily="18" charset="0"/>
-              </a:rPr>
-              <a:t>3</a:t>
-            </a:r>
-            <a:r>
-              <a:rPr lang="en-US" sz="1800" b="0" i="0" u="none" strike="noStrike" dirty="0">
-                <a:solidFill>
-                  <a:srgbClr val="000000"/>
-                </a:solidFill>
-                <a:effectLst/>
-                <a:latin typeface="Times New Roman" panose="02020603050405020304" pitchFamily="18" charset="0"/>
-              </a:rPr>
-              <a:t>Pacific Northwest National Laboratory, Richland, WA; </a:t>
-            </a:r>
-            <a:r>
-              <a:rPr lang="en-US" sz="1800" b="0" i="0" u="none" strike="noStrike" baseline="30000" dirty="0">
-                <a:solidFill>
-                  <a:srgbClr val="000000"/>
-                </a:solidFill>
-                <a:effectLst/>
-                <a:latin typeface="Times New Roman" panose="02020603050405020304" pitchFamily="18" charset="0"/>
-              </a:rPr>
-              <a:t>4</a:t>
-            </a:r>
-            <a:r>
-              <a:rPr lang="en-US" sz="1800" b="0" i="0" u="none" strike="noStrike" dirty="0">
-                <a:solidFill>
-                  <a:srgbClr val="000000"/>
-                </a:solidFill>
-                <a:effectLst/>
-                <a:latin typeface="Times New Roman" panose="02020603050405020304" pitchFamily="18" charset="0"/>
-              </a:rPr>
-              <a:t>Argonne National Laboratory, Lamont, IL</a:t>
-            </a:r>
             <a:endParaRPr lang="en-US" dirty="0"/>
           </a:p>
         </p:txBody>
@@ -816,8 +1082,8 @@
         </p:nvSpPr>
         <p:spPr>
           <a:xfrm>
-            <a:off x="1049722" y="4906559"/>
-            <a:ext cx="12344400" cy="8686799"/>
+            <a:off x="1399629" y="5887872"/>
+            <a:ext cx="16459200" cy="4309627"/>
           </a:xfrm>
           <a:prstGeom prst="rect">
             <a:avLst/>
@@ -827,7 +1093,7 @@
           <a:bodyPr/>
           <a:lstStyle>
             <a:lvl1pPr algn="l">
-              <a:defRPr sz="2800" b="0">
+              <a:defRPr sz="3360" b="0">
                 <a:solidFill>
                   <a:schemeClr val="tx1"/>
                 </a:solidFill>
@@ -837,7 +1103,7 @@
           <a:p>
             <a:pPr algn="ctr" rtl="0"/>
             <a:r>
-              <a:rPr lang="en-US" sz="3200" b="1" i="0" u="none" strike="noStrike" kern="1200" baseline="0" dirty="0">
+              <a:rPr lang="en-US" sz="3840" b="1" i="0" u="none" strike="noStrike" kern="1200" baseline="0" dirty="0">
                 <a:solidFill>
                   <a:srgbClr val="000000"/>
                 </a:solidFill>
@@ -866,8 +1132,8 @@
         </p:nvSpPr>
         <p:spPr>
           <a:xfrm>
-            <a:off x="14207361" y="4906559"/>
-            <a:ext cx="12435840" cy="8686799"/>
+            <a:off x="18943148" y="5887871"/>
+            <a:ext cx="16581120" cy="10424159"/>
           </a:xfrm>
           <a:prstGeom prst="rect">
             <a:avLst/>
@@ -877,7 +1143,7 @@
           <a:bodyPr/>
           <a:lstStyle>
             <a:lvl1pPr algn="ctr">
-              <a:defRPr sz="3200" b="1">
+              <a:defRPr sz="3840" b="1">
                 <a:solidFill>
                   <a:schemeClr val="tx1"/>
                 </a:solidFill>
@@ -888,7 +1154,7 @@
             <a:pPr lvl="0"/>
             <a:r>
               <a:rPr lang="en-US" dirty="0"/>
-              <a:t>The availability of redox sensitive is driven by soil moisture; saline surface water is a source of sulfate in the mid-Atlantic. </a:t>
+              <a:t>. </a:t>
             </a:r>
           </a:p>
           <a:p>
@@ -910,13 +1176,13 @@
             <a:spLocks noGrp="1"/>
           </p:cNvSpPr>
           <p:nvPr>
-            <p:ph type="body" sz="quarter" idx="14" hasCustomPrompt="1"/>
+            <p:ph type="body" sz="quarter" idx="14"/>
           </p:nvPr>
         </p:nvSpPr>
         <p:spPr>
           <a:xfrm>
-            <a:off x="1049722" y="14285925"/>
-            <a:ext cx="12344400" cy="8686800"/>
+            <a:off x="1399629" y="10884536"/>
+            <a:ext cx="16459200" cy="16682735"/>
           </a:xfrm>
           <a:prstGeom prst="rect">
             <a:avLst/>
@@ -926,7 +1192,7 @@
           <a:bodyPr/>
           <a:lstStyle>
             <a:lvl1pPr algn="ctr">
-              <a:defRPr sz="3200" b="1" i="0">
+              <a:defRPr sz="3840" b="1" i="0">
                 <a:solidFill>
                   <a:schemeClr val="tx1"/>
                 </a:solidFill>
@@ -934,10 +1200,7 @@
             </a:lvl1pPr>
           </a:lstStyle>
           <a:p>
-            <a:r>
-              <a:rPr lang="en-US" dirty="0"/>
-              <a:t>We monitor transects including upland coastal forest, forest transitioning to wetland, and wetlands in two study regions. </a:t>
-            </a:r>
+            <a:endParaRPr lang="en-US" dirty="0"/>
           </a:p>
         </p:txBody>
       </p:sp>
@@ -954,13 +1217,13 @@
             <a:spLocks noGrp="1"/>
           </p:cNvSpPr>
           <p:nvPr>
-            <p:ph type="body" sz="quarter" idx="15" hasCustomPrompt="1"/>
+            <p:ph type="body" sz="quarter" idx="15"/>
           </p:nvPr>
         </p:nvSpPr>
         <p:spPr>
           <a:xfrm>
-            <a:off x="14207361" y="14285925"/>
-            <a:ext cx="12435840" cy="8696718"/>
+            <a:off x="18943148" y="17143110"/>
+            <a:ext cx="16581120" cy="10436062"/>
           </a:xfrm>
           <a:prstGeom prst="rect">
             <a:avLst/>
@@ -970,7 +1233,7 @@
           <a:bodyPr/>
           <a:lstStyle>
             <a:lvl1pPr algn="ctr">
-              <a:defRPr sz="3200" b="1">
+              <a:defRPr sz="3840" b="1">
                 <a:solidFill>
                   <a:schemeClr val="tx1"/>
                 </a:solidFill>
@@ -979,10 +1242,7 @@
           </a:lstStyle>
           <a:p>
             <a:pPr lvl="0"/>
-            <a:r>
-              <a:rPr lang="en-US" dirty="0"/>
-              <a:t>Redox gradients observed across zones are driven by soil moisture and hydrology. </a:t>
-            </a:r>
+            <a:endParaRPr lang="en-US" dirty="0"/>
           </a:p>
         </p:txBody>
       </p:sp>
@@ -999,13 +1259,13 @@
             <a:spLocks noGrp="1"/>
           </p:cNvSpPr>
           <p:nvPr>
-            <p:ph type="body" sz="quarter" idx="16" hasCustomPrompt="1"/>
+            <p:ph type="body" sz="quarter" idx="16"/>
           </p:nvPr>
         </p:nvSpPr>
         <p:spPr>
           <a:xfrm>
-            <a:off x="1049722" y="23665292"/>
-            <a:ext cx="12344400" cy="8686800"/>
+            <a:off x="1399629" y="28398350"/>
+            <a:ext cx="16459200" cy="10424160"/>
           </a:xfrm>
           <a:prstGeom prst="rect">
             <a:avLst/>
@@ -1015,7 +1275,7 @@
           <a:bodyPr/>
           <a:lstStyle>
             <a:lvl1pPr algn="ctr">
-              <a:defRPr sz="3200" b="1">
+              <a:defRPr sz="3840" b="1">
                 <a:solidFill>
                   <a:schemeClr val="tx1"/>
                 </a:solidFill>
@@ -1024,10 +1284,7 @@
           </a:lstStyle>
           <a:p>
             <a:pPr lvl="0"/>
-            <a:r>
-              <a:rPr lang="en-US" dirty="0"/>
-              <a:t>Soil moisture and hydrology vary across the transects, inundation time and moisture increase from upland to wetland. </a:t>
-            </a:r>
+            <a:endParaRPr lang="en-US" dirty="0"/>
           </a:p>
         </p:txBody>
       </p:sp>
@@ -1044,13 +1301,13 @@
             <a:spLocks noGrp="1"/>
           </p:cNvSpPr>
           <p:nvPr>
-            <p:ph type="body" sz="quarter" idx="17" hasCustomPrompt="1"/>
+            <p:ph type="body" sz="quarter" idx="17"/>
           </p:nvPr>
         </p:nvSpPr>
         <p:spPr>
           <a:xfrm>
-            <a:off x="14207361" y="23665292"/>
-            <a:ext cx="12435840" cy="8686800"/>
+            <a:off x="18943148" y="28398350"/>
+            <a:ext cx="16581120" cy="10424160"/>
           </a:xfrm>
           <a:prstGeom prst="rect">
             <a:avLst/>
@@ -1060,7 +1317,7 @@
           <a:bodyPr/>
           <a:lstStyle>
             <a:lvl1pPr algn="ctr">
-              <a:defRPr sz="3200" b="1">
+              <a:defRPr sz="3840" b="1">
                 <a:solidFill>
                   <a:schemeClr val="tx1"/>
                 </a:solidFill>
@@ -1069,58 +1326,10 @@
           </a:lstStyle>
           <a:p>
             <a:pPr lvl="0"/>
-            <a:r>
-              <a:rPr lang="en-US" dirty="0"/>
-              <a:t>Methane emissions increase from upland to wetland across the salinity gradient, suggesting inundation is the major driver of ecosystem function. </a:t>
-            </a:r>
+            <a:endParaRPr lang="en-US" dirty="0"/>
           </a:p>
         </p:txBody>
       </p:sp>
-      <p:pic>
-        <p:nvPicPr>
-          <p:cNvPr id="1026" name="Picture 2">
-            <a:extLst>
-              <a:ext uri="{FF2B5EF4-FFF2-40B4-BE49-F238E27FC236}">
-                <a16:creationId xmlns:a16="http://schemas.microsoft.com/office/drawing/2014/main" id="{E3DAD434-E52C-21EF-CF89-8E5DB79F9485}"/>
-              </a:ext>
-            </a:extLst>
-          </p:cNvPr>
-          <p:cNvPicPr>
-            <a:picLocks noChangeAspect="1" noChangeArrowheads="1"/>
-          </p:cNvPicPr>
-          <p:nvPr userDrawn="1"/>
-        </p:nvPicPr>
-        <p:blipFill rotWithShape="1">
-          <a:blip r:embed="rId2">
-            <a:extLst>
-              <a:ext uri="{28A0092B-C50C-407E-A947-70E740481C1C}">
-                <a14:useLocalDpi xmlns:a14="http://schemas.microsoft.com/office/drawing/2010/main" val="0"/>
-              </a:ext>
-            </a:extLst>
-          </a:blip>
-          <a:srcRect b="4348"/>
-          <a:stretch/>
-        </p:blipFill>
-        <p:spPr bwMode="auto">
-          <a:xfrm>
-            <a:off x="3082804" y="7767419"/>
-            <a:ext cx="8822122" cy="5825939"/>
-          </a:xfrm>
-          <a:prstGeom prst="rect">
-            <a:avLst/>
-          </a:prstGeom>
-          <a:noFill/>
-          <a:extLst>
-            <a:ext uri="{909E8E84-426E-40DD-AFC4-6F175D3DCCD1}">
-              <a14:hiddenFill xmlns:a14="http://schemas.microsoft.com/office/drawing/2010/main">
-                <a:solidFill>
-                  <a:srgbClr val="FFFFFF"/>
-                </a:solidFill>
-              </a14:hiddenFill>
-            </a:ext>
-          </a:extLst>
-        </p:spPr>
-      </p:pic>
       <p:sp>
         <p:nvSpPr>
           <p:cNvPr id="2" name="TextBox 1">
@@ -1135,8 +1344,8 @@
         </p:nvSpPr>
         <p:spPr>
           <a:xfrm>
-            <a:off x="1136893" y="4848516"/>
-            <a:ext cx="12344400" cy="4021614"/>
+            <a:off x="1515857" y="5818219"/>
+            <a:ext cx="16459200" cy="5101653"/>
           </a:xfrm>
           <a:prstGeom prst="rect">
             <a:avLst/>
@@ -1151,14 +1360,14 @@
           <a:p>
             <a:pPr algn="ctr" rtl="0">
               <a:spcBef>
-                <a:spcPts val="1000"/>
+                <a:spcPts val="1200"/>
               </a:spcBef>
               <a:spcAft>
                 <a:spcPts val="0"/>
               </a:spcAft>
             </a:pPr>
             <a:r>
-              <a:rPr lang="en-US" sz="3200" b="1" i="0" u="none" strike="noStrike" dirty="0">
+              <a:rPr lang="en-US" sz="3840" b="1" i="0" u="none" strike="noStrike" dirty="0">
                 <a:solidFill>
                   <a:srgbClr val="000000"/>
                 </a:solidFill>
@@ -1169,7 +1378,7 @@
               <a:t>Hypothesis: </a:t>
             </a:r>
             <a:r>
-              <a:rPr lang="en-US" sz="3200" b="0" i="0" u="none" strike="noStrike" dirty="0">
+              <a:rPr lang="en-US" sz="3840" b="0" i="0" u="none" strike="noStrike" dirty="0">
                 <a:solidFill>
                   <a:srgbClr val="000000"/>
                 </a:solidFill>
@@ -1180,7 +1389,7 @@
               <a:t>There is a hierarchical structure to </a:t>
             </a:r>
             <a:r>
-              <a:rPr lang="en-US" sz="3200" b="0" i="0" u="sng" dirty="0">
+              <a:rPr lang="en-US" sz="3840" b="0" i="0" u="sng" dirty="0">
                 <a:solidFill>
                   <a:srgbClr val="000000"/>
                 </a:solidFill>
@@ -1191,7 +1400,7 @@
               <a:t>spatial </a:t>
             </a:r>
             <a:r>
-              <a:rPr lang="en-US" sz="3200" b="0" i="0" u="none" strike="noStrike" dirty="0">
+              <a:rPr lang="en-US" sz="3840" b="0" i="0" u="none" strike="noStrike" dirty="0">
                 <a:solidFill>
                   <a:srgbClr val="000000"/>
                 </a:solidFill>
@@ -1201,7 +1410,7 @@
               </a:rPr>
               <a:t>variation in ecosystem structure and function at the coastal TAI that is set by:</a:t>
             </a:r>
-            <a:endParaRPr lang="en-US" sz="3200" b="0" dirty="0">
+            <a:endParaRPr lang="en-US" sz="3840" b="0" dirty="0">
               <a:effectLst/>
               <a:latin typeface="Arial" panose="020B0604020202020204" pitchFamily="34" charset="0"/>
               <a:cs typeface="Arial" panose="020B0604020202020204" pitchFamily="34" charset="0"/>
@@ -1210,14 +1419,14 @@
           <a:p>
             <a:pPr algn="ctr" rtl="0">
               <a:spcBef>
-                <a:spcPts val="1000"/>
+                <a:spcPts val="1200"/>
               </a:spcBef>
               <a:spcAft>
                 <a:spcPts val="0"/>
               </a:spcAft>
             </a:pPr>
             <a:r>
-              <a:rPr lang="en-US" sz="3200" b="0" i="0" u="none" strike="noStrike" dirty="0">
+              <a:rPr lang="en-US" sz="3840" b="0" i="0" u="none" strike="noStrike" dirty="0">
                 <a:solidFill>
                   <a:srgbClr val="000000"/>
                 </a:solidFill>
@@ -1228,7 +1437,7 @@
               <a:t>1) the </a:t>
             </a:r>
             <a:r>
-              <a:rPr lang="en-US" sz="3200" b="1" i="0" u="none" strike="noStrike" dirty="0">
+              <a:rPr lang="en-US" sz="3840" b="1" i="0" u="none" strike="noStrike" dirty="0">
                 <a:solidFill>
                   <a:srgbClr val="000000"/>
                 </a:solidFill>
@@ -1238,7 +1447,7 @@
               </a:rPr>
               <a:t>depth and duration of soil saturation </a:t>
             </a:r>
-            <a:endParaRPr lang="en-US" sz="3200" b="0" dirty="0">
+            <a:endParaRPr lang="en-US" sz="3840" b="0" dirty="0">
               <a:effectLst/>
               <a:latin typeface="Arial" panose="020B0604020202020204" pitchFamily="34" charset="0"/>
               <a:cs typeface="Arial" panose="020B0604020202020204" pitchFamily="34" charset="0"/>
@@ -1247,14 +1456,14 @@
           <a:p>
             <a:pPr algn="ctr" rtl="0">
               <a:spcBef>
-                <a:spcPts val="1000"/>
+                <a:spcPts val="1200"/>
               </a:spcBef>
               <a:spcAft>
                 <a:spcPts val="0"/>
               </a:spcAft>
             </a:pPr>
             <a:r>
-              <a:rPr lang="en-US" sz="3200" b="0" i="0" u="none" strike="noStrike" dirty="0">
+              <a:rPr lang="en-US" sz="3840" b="0" i="0" u="none" strike="noStrike" dirty="0">
                 <a:solidFill>
                   <a:srgbClr val="000000"/>
                 </a:solidFill>
@@ -1265,7 +1474,7 @@
               <a:t>2) the abundance of </a:t>
             </a:r>
             <a:r>
-              <a:rPr lang="en-US" sz="3200" b="1" i="0" u="none" strike="noStrike" dirty="0">
+              <a:rPr lang="en-US" sz="3840" b="1" i="0" u="none" strike="noStrike" dirty="0">
                 <a:solidFill>
                   <a:srgbClr val="000000"/>
                 </a:solidFill>
@@ -1279,14 +1488,14 @@
           <a:p>
             <a:pPr algn="ctr" rtl="0">
               <a:spcBef>
-                <a:spcPts val="1000"/>
+                <a:spcPts val="1200"/>
               </a:spcBef>
               <a:spcAft>
                 <a:spcPts val="0"/>
               </a:spcAft>
             </a:pPr>
             <a:r>
-              <a:rPr lang="en-US" sz="3200" b="0" dirty="0">
+              <a:rPr lang="en-US" sz="3840" b="0" dirty="0">
                 <a:effectLst/>
                 <a:latin typeface="Arial" panose="020B0604020202020204" pitchFamily="34" charset="0"/>
                 <a:cs typeface="Arial" panose="020B0604020202020204" pitchFamily="34" charset="0"/>
@@ -1294,7 +1503,7 @@
               <a:t>3) their</a:t>
             </a:r>
             <a:r>
-              <a:rPr lang="en-US" sz="3200" b="1" dirty="0">
+              <a:rPr lang="en-US" sz="3840" b="1" dirty="0">
                 <a:effectLst/>
                 <a:latin typeface="Arial" panose="020B0604020202020204" pitchFamily="34" charset="0"/>
                 <a:cs typeface="Arial" panose="020B0604020202020204" pitchFamily="34" charset="0"/>
@@ -1305,13 +1514,13 @@
           <a:p>
             <a:pPr algn="ctr" rtl="0">
               <a:spcBef>
-                <a:spcPts val="1000"/>
+                <a:spcPts val="1200"/>
               </a:spcBef>
               <a:spcAft>
                 <a:spcPts val="0"/>
               </a:spcAft>
             </a:pPr>
-            <a:endParaRPr lang="en-US" b="0" dirty="0">
+            <a:endParaRPr lang="en-US" sz="4676" b="0" dirty="0">
               <a:effectLst/>
               <a:latin typeface="Arial" panose="020B0604020202020204" pitchFamily="34" charset="0"/>
               <a:cs typeface="Arial" panose="020B0604020202020204" pitchFamily="34" charset="0"/>
@@ -1319,385 +1528,10 @@
           </a:p>
           <a:p>
             <a:pPr algn="ctr"/>
-            <a:endParaRPr lang="en-US" dirty="0">
+            <a:endParaRPr lang="en-US" sz="4676" dirty="0">
               <a:latin typeface="Arial" panose="020B0604020202020204" pitchFamily="34" charset="0"/>
               <a:cs typeface="Arial" panose="020B0604020202020204" pitchFamily="34" charset="0"/>
             </a:endParaRPr>
-          </a:p>
-        </p:txBody>
-      </p:sp>
-      <p:pic>
-        <p:nvPicPr>
-          <p:cNvPr id="1028" name="Picture 4">
-            <a:extLst>
-              <a:ext uri="{FF2B5EF4-FFF2-40B4-BE49-F238E27FC236}">
-                <a16:creationId xmlns:a16="http://schemas.microsoft.com/office/drawing/2014/main" id="{7D448C49-0C1B-E954-193D-E55443DB7E4D}"/>
-              </a:ext>
-            </a:extLst>
-          </p:cNvPr>
-          <p:cNvPicPr>
-            <a:picLocks noChangeAspect="1" noChangeArrowheads="1"/>
-          </p:cNvPicPr>
-          <p:nvPr userDrawn="1"/>
-        </p:nvPicPr>
-        <p:blipFill>
-          <a:blip r:embed="rId3">
-            <a:extLst>
-              <a:ext uri="{28A0092B-C50C-407E-A947-70E740481C1C}">
-                <a14:useLocalDpi xmlns:a14="http://schemas.microsoft.com/office/drawing/2010/main" val="0"/>
-              </a:ext>
-            </a:extLst>
-          </a:blip>
-          <a:srcRect/>
-          <a:stretch>
-            <a:fillRect/>
-          </a:stretch>
-        </p:blipFill>
-        <p:spPr bwMode="auto">
-          <a:xfrm>
-            <a:off x="3082804" y="15873275"/>
-            <a:ext cx="7869605" cy="4723492"/>
-          </a:xfrm>
-          <a:prstGeom prst="rect">
-            <a:avLst/>
-          </a:prstGeom>
-          <a:noFill/>
-          <a:extLst>
-            <a:ext uri="{909E8E84-426E-40DD-AFC4-6F175D3DCCD1}">
-              <a14:hiddenFill xmlns:a14="http://schemas.microsoft.com/office/drawing/2010/main">
-                <a:solidFill>
-                  <a:srgbClr val="FFFFFF"/>
-                </a:solidFill>
-              </a14:hiddenFill>
-            </a:ext>
-          </a:extLst>
-        </p:spPr>
-      </p:pic>
-      <p:pic>
-        <p:nvPicPr>
-          <p:cNvPr id="8" name="Picture 7">
-            <a:extLst>
-              <a:ext uri="{FF2B5EF4-FFF2-40B4-BE49-F238E27FC236}">
-                <a16:creationId xmlns:a16="http://schemas.microsoft.com/office/drawing/2014/main" id="{8C23AF20-6302-6F05-533A-18008226ABDE}"/>
-              </a:ext>
-            </a:extLst>
-          </p:cNvPr>
-          <p:cNvPicPr>
-            <a:picLocks noChangeAspect="1"/>
-          </p:cNvPicPr>
-          <p:nvPr userDrawn="1"/>
-        </p:nvPicPr>
-        <p:blipFill>
-          <a:blip r:embed="rId4"/>
-          <a:stretch>
-            <a:fillRect/>
-          </a:stretch>
-        </p:blipFill>
-        <p:spPr>
-          <a:xfrm>
-            <a:off x="14343536" y="15417797"/>
-            <a:ext cx="12163490" cy="6390659"/>
-          </a:xfrm>
-          <a:prstGeom prst="rect">
-            <a:avLst/>
-          </a:prstGeom>
-        </p:spPr>
-      </p:pic>
-      <p:pic>
-        <p:nvPicPr>
-          <p:cNvPr id="9" name="Picture 8">
-            <a:extLst>
-              <a:ext uri="{FF2B5EF4-FFF2-40B4-BE49-F238E27FC236}">
-                <a16:creationId xmlns:a16="http://schemas.microsoft.com/office/drawing/2014/main" id="{F612A36F-93E9-7EED-6722-54D07738DDD6}"/>
-              </a:ext>
-            </a:extLst>
-          </p:cNvPr>
-          <p:cNvPicPr>
-            <a:picLocks noChangeAspect="1"/>
-          </p:cNvPicPr>
-          <p:nvPr userDrawn="1"/>
-        </p:nvPicPr>
-        <p:blipFill rotWithShape="1">
-          <a:blip r:embed="rId5"/>
-          <a:srcRect t="10791"/>
-          <a:stretch/>
-        </p:blipFill>
-        <p:spPr>
-          <a:xfrm>
-            <a:off x="14367599" y="6593013"/>
-            <a:ext cx="11759198" cy="5748100"/>
-          </a:xfrm>
-          <a:prstGeom prst="rect">
-            <a:avLst/>
-          </a:prstGeom>
-        </p:spPr>
-      </p:pic>
-      <p:pic>
-        <p:nvPicPr>
-          <p:cNvPr id="10" name="Picture 9">
-            <a:extLst>
-              <a:ext uri="{FF2B5EF4-FFF2-40B4-BE49-F238E27FC236}">
-                <a16:creationId xmlns:a16="http://schemas.microsoft.com/office/drawing/2014/main" id="{F97BFD72-95EA-B95D-4E34-C555984AA9CF}"/>
-              </a:ext>
-            </a:extLst>
-          </p:cNvPr>
-          <p:cNvPicPr>
-            <a:picLocks noChangeAspect="1"/>
-          </p:cNvPicPr>
-          <p:nvPr userDrawn="1"/>
-        </p:nvPicPr>
-        <p:blipFill>
-          <a:blip r:embed="rId6"/>
-          <a:stretch>
-            <a:fillRect/>
-          </a:stretch>
-        </p:blipFill>
-        <p:spPr>
-          <a:xfrm>
-            <a:off x="20425281" y="25578321"/>
-            <a:ext cx="6163143" cy="6447241"/>
-          </a:xfrm>
-          <a:prstGeom prst="rect">
-            <a:avLst/>
-          </a:prstGeom>
-        </p:spPr>
-      </p:pic>
-      <p:pic>
-        <p:nvPicPr>
-          <p:cNvPr id="11" name="Picture 10">
-            <a:extLst>
-              <a:ext uri="{FF2B5EF4-FFF2-40B4-BE49-F238E27FC236}">
-                <a16:creationId xmlns:a16="http://schemas.microsoft.com/office/drawing/2014/main" id="{9556A4D9-E30B-7880-F8D4-F58E8DB18628}"/>
-              </a:ext>
-            </a:extLst>
-          </p:cNvPr>
-          <p:cNvPicPr>
-            <a:picLocks noChangeAspect="1"/>
-          </p:cNvPicPr>
-          <p:nvPr userDrawn="1"/>
-        </p:nvPicPr>
-        <p:blipFill>
-          <a:blip r:embed="rId7"/>
-          <a:stretch>
-            <a:fillRect/>
-          </a:stretch>
-        </p:blipFill>
-        <p:spPr>
-          <a:xfrm>
-            <a:off x="14109611" y="26060400"/>
-            <a:ext cx="6249914" cy="4924908"/>
-          </a:xfrm>
-          <a:prstGeom prst="rect">
-            <a:avLst/>
-          </a:prstGeom>
-        </p:spPr>
-      </p:pic>
-      <p:pic>
-        <p:nvPicPr>
-          <p:cNvPr id="12" name="Picture 11">
-            <a:extLst>
-              <a:ext uri="{FF2B5EF4-FFF2-40B4-BE49-F238E27FC236}">
-                <a16:creationId xmlns:a16="http://schemas.microsoft.com/office/drawing/2014/main" id="{600DBE1F-DBA4-432F-2CE7-9A02370754F0}"/>
-              </a:ext>
-            </a:extLst>
-          </p:cNvPr>
-          <p:cNvPicPr>
-            <a:picLocks noChangeAspect="1"/>
-          </p:cNvPicPr>
-          <p:nvPr userDrawn="1"/>
-        </p:nvPicPr>
-        <p:blipFill>
-          <a:blip r:embed="rId8"/>
-          <a:stretch>
-            <a:fillRect/>
-          </a:stretch>
-        </p:blipFill>
-        <p:spPr>
-          <a:xfrm>
-            <a:off x="1192876" y="25179579"/>
-            <a:ext cx="11647640" cy="6138621"/>
-          </a:xfrm>
-          <a:prstGeom prst="rect">
-            <a:avLst/>
-          </a:prstGeom>
-        </p:spPr>
-      </p:pic>
-      <p:pic>
-        <p:nvPicPr>
-          <p:cNvPr id="14" name="Picture 13">
-            <a:extLst>
-              <a:ext uri="{FF2B5EF4-FFF2-40B4-BE49-F238E27FC236}">
-                <a16:creationId xmlns:a16="http://schemas.microsoft.com/office/drawing/2014/main" id="{8CB6B30F-8038-D6CE-F940-82651B090D45}"/>
-              </a:ext>
-            </a:extLst>
-          </p:cNvPr>
-          <p:cNvPicPr>
-            <a:picLocks noChangeAspect="1"/>
-          </p:cNvPicPr>
-          <p:nvPr userDrawn="1"/>
-        </p:nvPicPr>
-        <p:blipFill>
-          <a:blip r:embed="rId9"/>
-          <a:stretch>
-            <a:fillRect/>
-          </a:stretch>
-        </p:blipFill>
-        <p:spPr>
-          <a:xfrm>
-            <a:off x="3734424" y="20736706"/>
-            <a:ext cx="7147086" cy="2207594"/>
-          </a:xfrm>
-          <a:prstGeom prst="rect">
-            <a:avLst/>
-          </a:prstGeom>
-        </p:spPr>
-      </p:pic>
-      <p:sp>
-        <p:nvSpPr>
-          <p:cNvPr id="16" name="TextBox 15">
-            <a:extLst>
-              <a:ext uri="{FF2B5EF4-FFF2-40B4-BE49-F238E27FC236}">
-                <a16:creationId xmlns:a16="http://schemas.microsoft.com/office/drawing/2014/main" id="{3598C78C-3D1C-E7D5-81A3-C84A617ED994}"/>
-              </a:ext>
-            </a:extLst>
-          </p:cNvPr>
-          <p:cNvSpPr txBox="1"/>
-          <p:nvPr userDrawn="1"/>
-        </p:nvSpPr>
-        <p:spPr>
-          <a:xfrm>
-            <a:off x="14415480" y="21871801"/>
-            <a:ext cx="5638176" cy="1046440"/>
-          </a:xfrm>
-          <a:prstGeom prst="rect">
-            <a:avLst/>
-          </a:prstGeom>
-          <a:noFill/>
-        </p:spPr>
-        <p:txBody>
-          <a:bodyPr wrap="square" rtlCol="0">
-            <a:spAutoFit/>
-          </a:bodyPr>
-          <a:lstStyle/>
-          <a:p>
-            <a:r>
-              <a:rPr lang="en-US" dirty="0">
-                <a:solidFill>
-                  <a:schemeClr val="accent1"/>
-                </a:solidFill>
-              </a:rPr>
-              <a:t>Maybe we can get lake </a:t>
-            </a:r>
-            <a:r>
-              <a:rPr lang="en-US" dirty="0" err="1">
-                <a:solidFill>
-                  <a:schemeClr val="accent1"/>
-                </a:solidFill>
-              </a:rPr>
-              <a:t>erie</a:t>
-            </a:r>
-            <a:r>
-              <a:rPr lang="en-US" dirty="0">
-                <a:solidFill>
-                  <a:schemeClr val="accent1"/>
-                </a:solidFill>
-              </a:rPr>
-              <a:t> redox profiles as well? </a:t>
-            </a:r>
-          </a:p>
-        </p:txBody>
-      </p:sp>
-      <p:sp>
-        <p:nvSpPr>
-          <p:cNvPr id="17" name="TextBox 16">
-            <a:extLst>
-              <a:ext uri="{FF2B5EF4-FFF2-40B4-BE49-F238E27FC236}">
-                <a16:creationId xmlns:a16="http://schemas.microsoft.com/office/drawing/2014/main" id="{2C0A0260-FD8F-5425-24CC-3D54BD120A1D}"/>
-              </a:ext>
-            </a:extLst>
-          </p:cNvPr>
-          <p:cNvSpPr txBox="1"/>
-          <p:nvPr userDrawn="1"/>
-        </p:nvSpPr>
-        <p:spPr>
-          <a:xfrm>
-            <a:off x="14311452" y="12510460"/>
-            <a:ext cx="8624748" cy="1046440"/>
-          </a:xfrm>
-          <a:prstGeom prst="rect">
-            <a:avLst/>
-          </a:prstGeom>
-          <a:noFill/>
-        </p:spPr>
-        <p:txBody>
-          <a:bodyPr wrap="square" rtlCol="0">
-            <a:spAutoFit/>
-          </a:bodyPr>
-          <a:lstStyle/>
-          <a:p>
-            <a:r>
-              <a:rPr lang="en-US" dirty="0">
-                <a:solidFill>
-                  <a:schemeClr val="accent1"/>
-                </a:solidFill>
-              </a:rPr>
-              <a:t>If there is a redox element of interest in LE we could put here? Also need to add SWH to this </a:t>
-            </a:r>
-          </a:p>
-        </p:txBody>
-      </p:sp>
-      <p:sp>
-        <p:nvSpPr>
-          <p:cNvPr id="18" name="TextBox 17">
-            <a:extLst>
-              <a:ext uri="{FF2B5EF4-FFF2-40B4-BE49-F238E27FC236}">
-                <a16:creationId xmlns:a16="http://schemas.microsoft.com/office/drawing/2014/main" id="{B3EFDF2F-6EC7-FE8C-EDAA-E8D55397FA64}"/>
-              </a:ext>
-            </a:extLst>
-          </p:cNvPr>
-          <p:cNvSpPr txBox="1"/>
-          <p:nvPr userDrawn="1"/>
-        </p:nvSpPr>
-        <p:spPr>
-          <a:xfrm>
-            <a:off x="1049720" y="31502342"/>
-            <a:ext cx="7408479" cy="1046440"/>
-          </a:xfrm>
-          <a:prstGeom prst="rect">
-            <a:avLst/>
-          </a:prstGeom>
-          <a:noFill/>
-        </p:spPr>
-        <p:txBody>
-          <a:bodyPr wrap="square" rtlCol="0">
-            <a:spAutoFit/>
-          </a:bodyPr>
-          <a:lstStyle/>
-          <a:p>
-            <a:r>
-              <a:rPr lang="en-US" dirty="0">
-                <a:solidFill>
-                  <a:schemeClr val="accent1"/>
-                </a:solidFill>
-              </a:rPr>
-              <a:t>Maybe we can get lake </a:t>
-            </a:r>
-            <a:r>
-              <a:rPr lang="en-US" dirty="0" err="1">
-                <a:solidFill>
-                  <a:schemeClr val="accent1"/>
-                </a:solidFill>
-              </a:rPr>
-              <a:t>erie</a:t>
-            </a:r>
-            <a:r>
-              <a:rPr lang="en-US" dirty="0">
-                <a:solidFill>
-                  <a:schemeClr val="accent1"/>
-                </a:solidFill>
-              </a:rPr>
-              <a:t> moisture or water level  here rather than just CB sites? </a:t>
-            </a:r>
           </a:p>
         </p:txBody>
       </p:sp>
@@ -1764,8 +1598,8 @@
         </p:blipFill>
         <p:spPr>
           <a:xfrm>
-            <a:off x="0" y="32461200"/>
-            <a:ext cx="27432000" cy="4114800"/>
+            <a:off x="0" y="38953440"/>
+            <a:ext cx="36576000" cy="4937760"/>
           </a:xfrm>
           <a:prstGeom prst="rect">
             <a:avLst/>
@@ -1786,8 +1620,8 @@
         </p:nvSpPr>
         <p:spPr>
           <a:xfrm rot="16200000">
-            <a:off x="15331571" y="20856195"/>
-            <a:ext cx="23381767" cy="400110"/>
+            <a:off x="22000880" y="25036669"/>
+            <a:ext cx="28058120" cy="461665"/>
           </a:xfrm>
           <a:prstGeom prst="rect">
             <a:avLst/>
@@ -1801,7 +1635,7 @@
           <a:lstStyle/>
           <a:p>
             <a:r>
-              <a:rPr lang="en-US" sz="2000" dirty="0">
+              <a:rPr lang="en-US" sz="2400" dirty="0">
                 <a:latin typeface="Arial Narrow" panose="020B0604020202020204" pitchFamily="34" charset="0"/>
                 <a:cs typeface="Arial Narrow" panose="020B0604020202020204" pitchFamily="34" charset="0"/>
               </a:rPr>
@@ -1825,7 +1659,7 @@
         <p:spPr>
           <a:xfrm>
             <a:off x="0" y="0"/>
-            <a:ext cx="27432000" cy="457200"/>
+            <a:ext cx="36576000" cy="548640"/>
           </a:xfrm>
           <a:prstGeom prst="rect">
             <a:avLst/>
@@ -1858,7 +1692,7 @@
           <a:lstStyle/>
           <a:p>
             <a:pPr algn="ctr"/>
-            <a:endParaRPr lang="en-US" sz="5167"/>
+            <a:endParaRPr lang="en-US" sz="6200"/>
           </a:p>
         </p:txBody>
       </p:sp>
@@ -1875,12 +1709,12 @@
   </p:sldLayoutIdLst>
   <p:txStyles>
     <p:titleStyle>
-      <a:lvl1pPr algn="l" defTabSz="2612569" rtl="0" eaLnBrk="1" latinLnBrk="0" hangingPunct="1">
+      <a:lvl1pPr algn="l" defTabSz="3135083" rtl="0" eaLnBrk="1" latinLnBrk="0" hangingPunct="1">
         <a:spcBef>
           <a:spcPct val="0"/>
         </a:spcBef>
         <a:buNone/>
-        <a:defRPr sz="16000" kern="1200">
+        <a:defRPr sz="19200" kern="1200">
           <a:solidFill>
             <a:srgbClr val="419758"/>
           </a:solidFill>
@@ -1891,13 +1725,13 @@
       </a:lvl1pPr>
     </p:titleStyle>
     <p:bodyStyle>
-      <a:lvl1pPr marL="0" indent="0" algn="l" defTabSz="2612569" rtl="0" eaLnBrk="1" latinLnBrk="0" hangingPunct="1">
+      <a:lvl1pPr marL="0" indent="0" algn="l" defTabSz="3135083" rtl="0" eaLnBrk="1" latinLnBrk="0" hangingPunct="1">
         <a:spcBef>
           <a:spcPct val="20000"/>
         </a:spcBef>
         <a:buFont typeface="Arial" pitchFamily="34" charset="0"/>
         <a:buNone/>
-        <a:defRPr sz="6167" kern="1200">
+        <a:defRPr sz="7400" kern="1200">
           <a:solidFill>
             <a:schemeClr val="tx1">
               <a:lumMod val="65000"/>
@@ -1909,13 +1743,13 @@
           <a:cs typeface="Arial" panose="020B0604020202020204" pitchFamily="34" charset="0"/>
         </a:defRPr>
       </a:lvl1pPr>
-      <a:lvl2pPr marL="2122712" indent="-816428" algn="l" defTabSz="2612569" rtl="0" eaLnBrk="1" latinLnBrk="0" hangingPunct="1">
+      <a:lvl2pPr marL="2547254" indent="-979714" algn="l" defTabSz="3135083" rtl="0" eaLnBrk="1" latinLnBrk="0" hangingPunct="1">
         <a:spcBef>
           <a:spcPct val="20000"/>
         </a:spcBef>
         <a:buFont typeface="Arial" pitchFamily="34" charset="0"/>
         <a:buChar char="–"/>
-        <a:defRPr sz="8000" kern="1200">
+        <a:defRPr sz="9600" kern="1200">
           <a:solidFill>
             <a:schemeClr val="tx1"/>
           </a:solidFill>
@@ -1924,13 +1758,13 @@
           <a:cs typeface="+mn-cs"/>
         </a:defRPr>
       </a:lvl2pPr>
-      <a:lvl3pPr marL="3265712" indent="-653143" algn="l" defTabSz="2612569" rtl="0" eaLnBrk="1" latinLnBrk="0" hangingPunct="1">
+      <a:lvl3pPr marL="3918854" indent="-783772" algn="l" defTabSz="3135083" rtl="0" eaLnBrk="1" latinLnBrk="0" hangingPunct="1">
         <a:spcBef>
           <a:spcPct val="20000"/>
         </a:spcBef>
         <a:buFont typeface="Arial" pitchFamily="34" charset="0"/>
         <a:buChar char="•"/>
-        <a:defRPr sz="6833" kern="1200">
+        <a:defRPr sz="8200" kern="1200">
           <a:solidFill>
             <a:schemeClr val="tx1"/>
           </a:solidFill>
@@ -1939,13 +1773,13 @@
           <a:cs typeface="+mn-cs"/>
         </a:defRPr>
       </a:lvl3pPr>
-      <a:lvl4pPr marL="4571996" indent="-653143" algn="l" defTabSz="2612569" rtl="0" eaLnBrk="1" latinLnBrk="0" hangingPunct="1">
+      <a:lvl4pPr marL="5486395" indent="-783772" algn="l" defTabSz="3135083" rtl="0" eaLnBrk="1" latinLnBrk="0" hangingPunct="1">
         <a:spcBef>
           <a:spcPct val="20000"/>
         </a:spcBef>
         <a:buFont typeface="Arial" pitchFamily="34" charset="0"/>
         <a:buChar char="–"/>
-        <a:defRPr sz="5833" kern="1200">
+        <a:defRPr sz="7000" kern="1200">
           <a:solidFill>
             <a:schemeClr val="tx1"/>
           </a:solidFill>
@@ -1954,13 +1788,13 @@
           <a:cs typeface="+mn-cs"/>
         </a:defRPr>
       </a:lvl4pPr>
-      <a:lvl5pPr marL="5878281" indent="-653143" algn="l" defTabSz="2612569" rtl="0" eaLnBrk="1" latinLnBrk="0" hangingPunct="1">
+      <a:lvl5pPr marL="7053937" indent="-783772" algn="l" defTabSz="3135083" rtl="0" eaLnBrk="1" latinLnBrk="0" hangingPunct="1">
         <a:spcBef>
           <a:spcPct val="20000"/>
         </a:spcBef>
         <a:buFont typeface="Arial" pitchFamily="34" charset="0"/>
         <a:buChar char="»"/>
-        <a:defRPr sz="5833" kern="1200">
+        <a:defRPr sz="7000" kern="1200">
           <a:solidFill>
             <a:schemeClr val="tx1"/>
           </a:solidFill>
@@ -1969,13 +1803,13 @@
           <a:cs typeface="+mn-cs"/>
         </a:defRPr>
       </a:lvl5pPr>
-      <a:lvl6pPr marL="7184565" indent="-653143" algn="l" defTabSz="2612569" rtl="0" eaLnBrk="1" latinLnBrk="0" hangingPunct="1">
+      <a:lvl6pPr marL="8621478" indent="-783772" algn="l" defTabSz="3135083" rtl="0" eaLnBrk="1" latinLnBrk="0" hangingPunct="1">
         <a:spcBef>
           <a:spcPct val="20000"/>
         </a:spcBef>
         <a:buFont typeface="Arial" pitchFamily="34" charset="0"/>
         <a:buChar char="•"/>
-        <a:defRPr sz="5833" kern="1200">
+        <a:defRPr sz="7000" kern="1200">
           <a:solidFill>
             <a:schemeClr val="tx1"/>
           </a:solidFill>
@@ -1984,13 +1818,13 @@
           <a:cs typeface="+mn-cs"/>
         </a:defRPr>
       </a:lvl6pPr>
-      <a:lvl7pPr marL="8490850" indent="-653143" algn="l" defTabSz="2612569" rtl="0" eaLnBrk="1" latinLnBrk="0" hangingPunct="1">
+      <a:lvl7pPr marL="10189020" indent="-783772" algn="l" defTabSz="3135083" rtl="0" eaLnBrk="1" latinLnBrk="0" hangingPunct="1">
         <a:spcBef>
           <a:spcPct val="20000"/>
         </a:spcBef>
         <a:buFont typeface="Arial" pitchFamily="34" charset="0"/>
         <a:buChar char="•"/>
-        <a:defRPr sz="5833" kern="1200">
+        <a:defRPr sz="7000" kern="1200">
           <a:solidFill>
             <a:schemeClr val="tx1"/>
           </a:solidFill>
@@ -1999,13 +1833,13 @@
           <a:cs typeface="+mn-cs"/>
         </a:defRPr>
       </a:lvl7pPr>
-      <a:lvl8pPr marL="9797136" indent="-653143" algn="l" defTabSz="2612569" rtl="0" eaLnBrk="1" latinLnBrk="0" hangingPunct="1">
+      <a:lvl8pPr marL="11756563" indent="-783772" algn="l" defTabSz="3135083" rtl="0" eaLnBrk="1" latinLnBrk="0" hangingPunct="1">
         <a:spcBef>
           <a:spcPct val="20000"/>
         </a:spcBef>
         <a:buFont typeface="Arial" pitchFamily="34" charset="0"/>
         <a:buChar char="•"/>
-        <a:defRPr sz="5833" kern="1200">
+        <a:defRPr sz="7000" kern="1200">
           <a:solidFill>
             <a:schemeClr val="tx1"/>
           </a:solidFill>
@@ -2014,13 +1848,13 @@
           <a:cs typeface="+mn-cs"/>
         </a:defRPr>
       </a:lvl8pPr>
-      <a:lvl9pPr marL="11103420" indent="-653143" algn="l" defTabSz="2612569" rtl="0" eaLnBrk="1" latinLnBrk="0" hangingPunct="1">
+      <a:lvl9pPr marL="13324104" indent="-783772" algn="l" defTabSz="3135083" rtl="0" eaLnBrk="1" latinLnBrk="0" hangingPunct="1">
         <a:spcBef>
           <a:spcPct val="20000"/>
         </a:spcBef>
         <a:buFont typeface="Arial" pitchFamily="34" charset="0"/>
         <a:buChar char="•"/>
-        <a:defRPr sz="5833" kern="1200">
+        <a:defRPr sz="7000" kern="1200">
           <a:solidFill>
             <a:schemeClr val="tx1"/>
           </a:solidFill>
@@ -2034,8 +1868,8 @@
       <a:defPPr>
         <a:defRPr lang="en-US"/>
       </a:defPPr>
-      <a:lvl1pPr marL="0" algn="l" defTabSz="2612569" rtl="0" eaLnBrk="1" latinLnBrk="0" hangingPunct="1">
-        <a:defRPr sz="5167" kern="1200">
+      <a:lvl1pPr marL="0" algn="l" defTabSz="3135083" rtl="0" eaLnBrk="1" latinLnBrk="0" hangingPunct="1">
+        <a:defRPr sz="6200" kern="1200">
           <a:solidFill>
             <a:schemeClr val="tx1"/>
           </a:solidFill>
@@ -2044,8 +1878,8 @@
           <a:cs typeface="+mn-cs"/>
         </a:defRPr>
       </a:lvl1pPr>
-      <a:lvl2pPr marL="1306284" algn="l" defTabSz="2612569" rtl="0" eaLnBrk="1" latinLnBrk="0" hangingPunct="1">
-        <a:defRPr sz="5167" kern="1200">
+      <a:lvl2pPr marL="1567541" algn="l" defTabSz="3135083" rtl="0" eaLnBrk="1" latinLnBrk="0" hangingPunct="1">
+        <a:defRPr sz="6200" kern="1200">
           <a:solidFill>
             <a:schemeClr val="tx1"/>
           </a:solidFill>
@@ -2054,8 +1888,8 @@
           <a:cs typeface="+mn-cs"/>
         </a:defRPr>
       </a:lvl2pPr>
-      <a:lvl3pPr marL="2612569" algn="l" defTabSz="2612569" rtl="0" eaLnBrk="1" latinLnBrk="0" hangingPunct="1">
-        <a:defRPr sz="5167" kern="1200">
+      <a:lvl3pPr marL="3135083" algn="l" defTabSz="3135083" rtl="0" eaLnBrk="1" latinLnBrk="0" hangingPunct="1">
+        <a:defRPr sz="6200" kern="1200">
           <a:solidFill>
             <a:schemeClr val="tx1"/>
           </a:solidFill>
@@ -2064,8 +1898,8 @@
           <a:cs typeface="+mn-cs"/>
         </a:defRPr>
       </a:lvl3pPr>
-      <a:lvl4pPr marL="3918855" algn="l" defTabSz="2612569" rtl="0" eaLnBrk="1" latinLnBrk="0" hangingPunct="1">
-        <a:defRPr sz="5167" kern="1200">
+      <a:lvl4pPr marL="4702626" algn="l" defTabSz="3135083" rtl="0" eaLnBrk="1" latinLnBrk="0" hangingPunct="1">
+        <a:defRPr sz="6200" kern="1200">
           <a:solidFill>
             <a:schemeClr val="tx1"/>
           </a:solidFill>
@@ -2074,8 +1908,8 @@
           <a:cs typeface="+mn-cs"/>
         </a:defRPr>
       </a:lvl4pPr>
-      <a:lvl5pPr marL="5225140" algn="l" defTabSz="2612569" rtl="0" eaLnBrk="1" latinLnBrk="0" hangingPunct="1">
-        <a:defRPr sz="5167" kern="1200">
+      <a:lvl5pPr marL="6270168" algn="l" defTabSz="3135083" rtl="0" eaLnBrk="1" latinLnBrk="0" hangingPunct="1">
+        <a:defRPr sz="6200" kern="1200">
           <a:solidFill>
             <a:schemeClr val="tx1"/>
           </a:solidFill>
@@ -2084,8 +1918,8 @@
           <a:cs typeface="+mn-cs"/>
         </a:defRPr>
       </a:lvl5pPr>
-      <a:lvl6pPr marL="6531424" algn="l" defTabSz="2612569" rtl="0" eaLnBrk="1" latinLnBrk="0" hangingPunct="1">
-        <a:defRPr sz="5167" kern="1200">
+      <a:lvl6pPr marL="7837709" algn="l" defTabSz="3135083" rtl="0" eaLnBrk="1" latinLnBrk="0" hangingPunct="1">
+        <a:defRPr sz="6200" kern="1200">
           <a:solidFill>
             <a:schemeClr val="tx1"/>
           </a:solidFill>
@@ -2094,8 +1928,8 @@
           <a:cs typeface="+mn-cs"/>
         </a:defRPr>
       </a:lvl6pPr>
-      <a:lvl7pPr marL="7837708" algn="l" defTabSz="2612569" rtl="0" eaLnBrk="1" latinLnBrk="0" hangingPunct="1">
-        <a:defRPr sz="5167" kern="1200">
+      <a:lvl7pPr marL="9405250" algn="l" defTabSz="3135083" rtl="0" eaLnBrk="1" latinLnBrk="0" hangingPunct="1">
+        <a:defRPr sz="6200" kern="1200">
           <a:solidFill>
             <a:schemeClr val="tx1"/>
           </a:solidFill>
@@ -2104,8 +1938,8 @@
           <a:cs typeface="+mn-cs"/>
         </a:defRPr>
       </a:lvl7pPr>
-      <a:lvl8pPr marL="9143993" algn="l" defTabSz="2612569" rtl="0" eaLnBrk="1" latinLnBrk="0" hangingPunct="1">
-        <a:defRPr sz="5167" kern="1200">
+      <a:lvl8pPr marL="10972792" algn="l" defTabSz="3135083" rtl="0" eaLnBrk="1" latinLnBrk="0" hangingPunct="1">
+        <a:defRPr sz="6200" kern="1200">
           <a:solidFill>
             <a:schemeClr val="tx1"/>
           </a:solidFill>
@@ -2114,8 +1948,8 @@
           <a:cs typeface="+mn-cs"/>
         </a:defRPr>
       </a:lvl8pPr>
-      <a:lvl9pPr marL="10450277" algn="l" defTabSz="2612569" rtl="0" eaLnBrk="1" latinLnBrk="0" hangingPunct="1">
-        <a:defRPr sz="5167" kern="1200">
+      <a:lvl9pPr marL="12540332" algn="l" defTabSz="3135083" rtl="0" eaLnBrk="1" latinLnBrk="0" hangingPunct="1">
+        <a:defRPr sz="6200" kern="1200">
           <a:solidFill>
             <a:schemeClr val="tx1"/>
           </a:solidFill>
@@ -2154,8 +1988,8 @@
         </p:nvSpPr>
         <p:spPr>
           <a:xfrm rot="16200000">
-            <a:off x="-17145000" y="32385000"/>
-            <a:ext cx="7620000" cy="381000"/>
+            <a:off x="-20574000" y="38862000"/>
+            <a:ext cx="9144000" cy="457200"/>
           </a:xfrm>
           <a:prstGeom prst="rect">
             <a:avLst/>
@@ -2169,7 +2003,7 @@
           <a:lstStyle/>
           <a:p>
             <a:r>
-              <a:rPr lang="en-US" sz="1000" dirty="0">
+              <a:rPr lang="en-US" sz="1200" dirty="0">
                 <a:solidFill>
                   <a:schemeClr val="bg1">
                     <a:lumMod val="75000"/>
@@ -2204,7 +2038,10 @@
           <a:bodyPr/>
           <a:lstStyle/>
           <a:p>
-            <a:endParaRPr lang="en-US" dirty="0"/>
+            <a:r>
+              <a:rPr lang="en-US" dirty="0"/>
+              <a:t>Porewater sulfate varies across the coastal terrestrial-aquatic interface, sampling depths, and seasonally</a:t>
+            </a:r>
           </a:p>
         </p:txBody>
       </p:sp>
@@ -2229,31 +2066,14 @@
           <a:bodyPr/>
           <a:lstStyle/>
           <a:p>
-            <a:endParaRPr lang="en-US"/>
-          </a:p>
-        </p:txBody>
-      </p:sp>
-      <p:sp>
-        <p:nvSpPr>
-          <p:cNvPr id="7" name="Text Placeholder 6">
-            <a:extLst>
-              <a:ext uri="{FF2B5EF4-FFF2-40B4-BE49-F238E27FC236}">
-                <a16:creationId xmlns:a16="http://schemas.microsoft.com/office/drawing/2014/main" id="{A49C79F4-8D4A-AFB2-B2FB-211C124A5DB5}"/>
-              </a:ext>
-            </a:extLst>
-          </p:cNvPr>
-          <p:cNvSpPr>
-            <a:spLocks noGrp="1"/>
-          </p:cNvSpPr>
-          <p:nvPr>
-            <p:ph type="body" sz="quarter" idx="11"/>
-          </p:nvPr>
-        </p:nvSpPr>
-        <p:spPr/>
-        <p:txBody>
-          <a:bodyPr/>
-          <a:lstStyle/>
-          <a:p>
+            <a:r>
+              <a:rPr lang="en-US" sz="2880" b="1" dirty="0"/>
+              <a:t>Zoe Read, </a:t>
+            </a:r>
+            <a:r>
+              <a:rPr lang="en-US" sz="2880" dirty="0"/>
+              <a:t>Smithsonian Environmental Research Center, Maryland, USA</a:t>
+            </a:r>
             <a:endParaRPr lang="en-US" dirty="0"/>
           </a:p>
         </p:txBody>
@@ -2299,12 +2119,93 @@
             <p:ph type="body" sz="quarter" idx="14"/>
           </p:nvPr>
         </p:nvSpPr>
-        <p:spPr/>
+        <p:spPr>
+          <a:xfrm>
+            <a:off x="3088466" y="10884536"/>
+            <a:ext cx="10210270" cy="16682735"/>
+          </a:xfrm>
+        </p:spPr>
         <p:txBody>
           <a:bodyPr/>
           <a:lstStyle/>
           <a:p>
-            <a:endParaRPr lang="en-US"/>
+            <a:pPr algn="l"/>
+            <a:r>
+              <a:rPr lang="en-US" sz="4800" dirty="0">
+                <a:solidFill>
+                  <a:srgbClr val="75BFE2"/>
+                </a:solidFill>
+              </a:rPr>
+              <a:t>Background</a:t>
+            </a:r>
+            <a:endParaRPr lang="en-US" dirty="0"/>
+          </a:p>
+          <a:p>
+            <a:pPr marL="548640" indent="-548640" algn="l">
+              <a:buFont typeface="Arial" panose="020B0604020202020204" pitchFamily="34" charset="0"/>
+              <a:buChar char="•"/>
+            </a:pPr>
+            <a:r>
+              <a:rPr lang="en-US" dirty="0"/>
+              <a:t>We monitor transects including upland coastal forest, forest transitioning to wetland, and wetlands in the Chesapeake Bay Region at four sites that are oligohaline, mesohaline, and </a:t>
+            </a:r>
+            <a:r>
+              <a:rPr lang="en-US" dirty="0" err="1"/>
+              <a:t>polyhaline</a:t>
+            </a:r>
+            <a:r>
+              <a:rPr lang="en-US" dirty="0"/>
+              <a:t> </a:t>
+            </a:r>
+          </a:p>
+          <a:p>
+            <a:pPr marL="548640" indent="-548640" algn="l">
+              <a:buFont typeface="Arial" panose="020B0604020202020204" pitchFamily="34" charset="0"/>
+              <a:buChar char="•"/>
+            </a:pPr>
+            <a:r>
+              <a:rPr lang="en-US" dirty="0"/>
+              <a:t>Porewater sampling from 2022-2025  </a:t>
+            </a:r>
+          </a:p>
+          <a:p>
+            <a:pPr marL="548640" indent="-548640" algn="l">
+              <a:buFont typeface="Arial" panose="020B0604020202020204" pitchFamily="34" charset="0"/>
+              <a:buChar char="•"/>
+            </a:pPr>
+            <a:r>
+              <a:rPr lang="en-US" dirty="0"/>
+              <a:t>Analyzed for DIC, DOC, Total Alkalinity, CDOM, H</a:t>
+            </a:r>
+            <a:r>
+              <a:rPr lang="en-US" baseline="-25000" dirty="0"/>
+              <a:t>2</a:t>
+            </a:r>
+            <a:r>
+              <a:rPr lang="en-US" dirty="0"/>
+              <a:t>S, Cl</a:t>
+            </a:r>
+            <a:r>
+              <a:rPr lang="en-US" baseline="30000" dirty="0"/>
+              <a:t>-</a:t>
+            </a:r>
+            <a:r>
+              <a:rPr lang="en-US" dirty="0"/>
+              <a:t>, Nutrients, and SO</a:t>
+            </a:r>
+            <a:r>
+              <a:rPr lang="en-US" baseline="-25000" dirty="0"/>
+              <a:t>4</a:t>
+            </a:r>
+            <a:r>
+              <a:rPr lang="en-US" baseline="30000" dirty="0"/>
+              <a:t>2-</a:t>
+            </a:r>
+            <a:endParaRPr lang="en-US" dirty="0"/>
+          </a:p>
+          <a:p>
+            <a:pPr algn="l"/>
+            <a:endParaRPr lang="en-US" dirty="0"/>
           </a:p>
         </p:txBody>
       </p:sp>
@@ -2329,32 +2230,7 @@
           <a:bodyPr/>
           <a:lstStyle/>
           <a:p>
-            <a:endParaRPr lang="en-US"/>
-          </a:p>
-        </p:txBody>
-      </p:sp>
-      <p:sp>
-        <p:nvSpPr>
-          <p:cNvPr id="11" name="Text Placeholder 10">
-            <a:extLst>
-              <a:ext uri="{FF2B5EF4-FFF2-40B4-BE49-F238E27FC236}">
-                <a16:creationId xmlns:a16="http://schemas.microsoft.com/office/drawing/2014/main" id="{CC70C158-B8B1-73B0-0C7A-54B956AEA3BB}"/>
-              </a:ext>
-            </a:extLst>
-          </p:cNvPr>
-          <p:cNvSpPr>
-            <a:spLocks noGrp="1"/>
-          </p:cNvSpPr>
-          <p:nvPr>
-            <p:ph type="body" sz="quarter" idx="16"/>
-          </p:nvPr>
-        </p:nvSpPr>
-        <p:spPr/>
-        <p:txBody>
-          <a:bodyPr/>
-          <a:lstStyle/>
-          <a:p>
-            <a:endParaRPr lang="en-US"/>
+            <a:endParaRPr lang="en-US" dirty="0"/>
           </a:p>
         </p:txBody>
       </p:sp>
@@ -2383,6 +2259,2026 @@
           </a:p>
         </p:txBody>
       </p:sp>
+      <p:grpSp>
+        <p:nvGrpSpPr>
+          <p:cNvPr id="4" name="Group 3">
+            <a:extLst>
+              <a:ext uri="{FF2B5EF4-FFF2-40B4-BE49-F238E27FC236}">
+                <a16:creationId xmlns:a16="http://schemas.microsoft.com/office/drawing/2014/main" id="{F300F081-8329-7FA3-9182-15729BEF52AA}"/>
+              </a:ext>
+            </a:extLst>
+          </p:cNvPr>
+          <p:cNvGrpSpPr/>
+          <p:nvPr/>
+        </p:nvGrpSpPr>
+        <p:grpSpPr>
+          <a:xfrm>
+            <a:off x="3739467" y="12855514"/>
+            <a:ext cx="13164319" cy="10251881"/>
+            <a:chOff x="293462" y="9708209"/>
+            <a:chExt cx="11273530" cy="7689140"/>
+          </a:xfrm>
+        </p:grpSpPr>
+        <p:sp>
+          <p:nvSpPr>
+            <p:cNvPr id="5" name="Text Placeholder 11">
+              <a:extLst>
+                <a:ext uri="{FF2B5EF4-FFF2-40B4-BE49-F238E27FC236}">
+                  <a16:creationId xmlns:a16="http://schemas.microsoft.com/office/drawing/2014/main" id="{3016F121-A2BA-A984-CB58-265698576097}"/>
+                </a:ext>
+              </a:extLst>
+            </p:cNvPr>
+            <p:cNvSpPr txBox="1">
+              <a:spLocks/>
+            </p:cNvSpPr>
+            <p:nvPr/>
+          </p:nvSpPr>
+          <p:spPr>
+            <a:xfrm>
+              <a:off x="353828" y="10585278"/>
+              <a:ext cx="6170205" cy="2441318"/>
+            </a:xfrm>
+            <a:prstGeom prst="rect">
+              <a:avLst/>
+            </a:prstGeom>
+            <a:ln>
+              <a:noFill/>
+            </a:ln>
+          </p:spPr>
+          <p:txBody>
+            <a:bodyPr/>
+            <a:lstStyle>
+              <a:lvl1pPr marL="0" indent="0" algn="l" defTabSz="1567510" rtl="0" eaLnBrk="1" latinLnBrk="0" hangingPunct="1">
+                <a:spcBef>
+                  <a:spcPct val="20000"/>
+                </a:spcBef>
+                <a:buFont typeface="Arial" pitchFamily="34" charset="0"/>
+                <a:buNone/>
+                <a:defRPr sz="2200" kern="1200">
+                  <a:solidFill>
+                    <a:schemeClr val="tx1"/>
+                  </a:solidFill>
+                  <a:latin typeface="Arial" panose="020B0604020202020204" pitchFamily="34" charset="0"/>
+                  <a:ea typeface="+mn-ea"/>
+                  <a:cs typeface="Arial" panose="020B0604020202020204" pitchFamily="34" charset="0"/>
+                </a:defRPr>
+              </a:lvl1pPr>
+              <a:lvl2pPr marL="1273602" indent="-489847" algn="l" defTabSz="1567510" rtl="0" eaLnBrk="1" latinLnBrk="0" hangingPunct="1">
+                <a:spcBef>
+                  <a:spcPct val="20000"/>
+                </a:spcBef>
+                <a:buFont typeface="Arial" pitchFamily="34" charset="0"/>
+                <a:buChar char="–"/>
+                <a:defRPr sz="4800" kern="1200">
+                  <a:solidFill>
+                    <a:schemeClr val="tx1"/>
+                  </a:solidFill>
+                  <a:latin typeface="+mn-lt"/>
+                  <a:ea typeface="+mn-ea"/>
+                  <a:cs typeface="+mn-cs"/>
+                </a:defRPr>
+              </a:lvl2pPr>
+              <a:lvl3pPr marL="1959388" indent="-391878" algn="l" defTabSz="1567510" rtl="0" eaLnBrk="1" latinLnBrk="0" hangingPunct="1">
+                <a:spcBef>
+                  <a:spcPct val="20000"/>
+                </a:spcBef>
+                <a:buFont typeface="Arial" pitchFamily="34" charset="0"/>
+                <a:buChar char="•"/>
+                <a:defRPr sz="4100" kern="1200">
+                  <a:solidFill>
+                    <a:schemeClr val="tx1"/>
+                  </a:solidFill>
+                  <a:latin typeface="+mn-lt"/>
+                  <a:ea typeface="+mn-ea"/>
+                  <a:cs typeface="+mn-cs"/>
+                </a:defRPr>
+              </a:lvl3pPr>
+              <a:lvl4pPr marL="2743143" indent="-391878" algn="l" defTabSz="1567510" rtl="0" eaLnBrk="1" latinLnBrk="0" hangingPunct="1">
+                <a:spcBef>
+                  <a:spcPct val="20000"/>
+                </a:spcBef>
+                <a:buFont typeface="Arial" pitchFamily="34" charset="0"/>
+                <a:buChar char="–"/>
+                <a:defRPr sz="3500" kern="1200">
+                  <a:solidFill>
+                    <a:schemeClr val="tx1"/>
+                  </a:solidFill>
+                  <a:latin typeface="+mn-lt"/>
+                  <a:ea typeface="+mn-ea"/>
+                  <a:cs typeface="+mn-cs"/>
+                </a:defRPr>
+              </a:lvl4pPr>
+              <a:lvl5pPr marL="3526898" indent="-391878" algn="l" defTabSz="1567510" rtl="0" eaLnBrk="1" latinLnBrk="0" hangingPunct="1">
+                <a:spcBef>
+                  <a:spcPct val="20000"/>
+                </a:spcBef>
+                <a:buFont typeface="Arial" pitchFamily="34" charset="0"/>
+                <a:buChar char="»"/>
+                <a:defRPr sz="3500" kern="1200">
+                  <a:solidFill>
+                    <a:schemeClr val="tx1"/>
+                  </a:solidFill>
+                  <a:latin typeface="+mn-lt"/>
+                  <a:ea typeface="+mn-ea"/>
+                  <a:cs typeface="+mn-cs"/>
+                </a:defRPr>
+              </a:lvl5pPr>
+              <a:lvl6pPr marL="4310653" indent="-391878" algn="l" defTabSz="1567510" rtl="0" eaLnBrk="1" latinLnBrk="0" hangingPunct="1">
+                <a:spcBef>
+                  <a:spcPct val="20000"/>
+                </a:spcBef>
+                <a:buFont typeface="Arial" pitchFamily="34" charset="0"/>
+                <a:buChar char="•"/>
+                <a:defRPr sz="3500" kern="1200">
+                  <a:solidFill>
+                    <a:schemeClr val="tx1"/>
+                  </a:solidFill>
+                  <a:latin typeface="+mn-lt"/>
+                  <a:ea typeface="+mn-ea"/>
+                  <a:cs typeface="+mn-cs"/>
+                </a:defRPr>
+              </a:lvl6pPr>
+              <a:lvl7pPr marL="5094408" indent="-391878" algn="l" defTabSz="1567510" rtl="0" eaLnBrk="1" latinLnBrk="0" hangingPunct="1">
+                <a:spcBef>
+                  <a:spcPct val="20000"/>
+                </a:spcBef>
+                <a:buFont typeface="Arial" pitchFamily="34" charset="0"/>
+                <a:buChar char="•"/>
+                <a:defRPr sz="3500" kern="1200">
+                  <a:solidFill>
+                    <a:schemeClr val="tx1"/>
+                  </a:solidFill>
+                  <a:latin typeface="+mn-lt"/>
+                  <a:ea typeface="+mn-ea"/>
+                  <a:cs typeface="+mn-cs"/>
+                </a:defRPr>
+              </a:lvl7pPr>
+              <a:lvl8pPr marL="5878164" indent="-391878" algn="l" defTabSz="1567510" rtl="0" eaLnBrk="1" latinLnBrk="0" hangingPunct="1">
+                <a:spcBef>
+                  <a:spcPct val="20000"/>
+                </a:spcBef>
+                <a:buFont typeface="Arial" pitchFamily="34" charset="0"/>
+                <a:buChar char="•"/>
+                <a:defRPr sz="3500" kern="1200">
+                  <a:solidFill>
+                    <a:schemeClr val="tx1"/>
+                  </a:solidFill>
+                  <a:latin typeface="+mn-lt"/>
+                  <a:ea typeface="+mn-ea"/>
+                  <a:cs typeface="+mn-cs"/>
+                </a:defRPr>
+              </a:lvl8pPr>
+              <a:lvl9pPr marL="6661919" indent="-391878" algn="l" defTabSz="1567510" rtl="0" eaLnBrk="1" latinLnBrk="0" hangingPunct="1">
+                <a:spcBef>
+                  <a:spcPct val="20000"/>
+                </a:spcBef>
+                <a:buFont typeface="Arial" pitchFamily="34" charset="0"/>
+                <a:buChar char="•"/>
+                <a:defRPr sz="3500" kern="1200">
+                  <a:solidFill>
+                    <a:schemeClr val="tx1"/>
+                  </a:solidFill>
+                  <a:latin typeface="+mn-lt"/>
+                  <a:ea typeface="+mn-ea"/>
+                  <a:cs typeface="+mn-cs"/>
+                </a:defRPr>
+              </a:lvl9pPr>
+            </a:lstStyle>
+            <a:p>
+              <a:endParaRPr lang="en-US" sz="3360" dirty="0">
+                <a:solidFill>
+                  <a:srgbClr val="419556"/>
+                </a:solidFill>
+              </a:endParaRPr>
+            </a:p>
+          </p:txBody>
+        </p:sp>
+        <p:grpSp>
+          <p:nvGrpSpPr>
+            <p:cNvPr id="13" name="Group 12">
+              <a:extLst>
+                <a:ext uri="{FF2B5EF4-FFF2-40B4-BE49-F238E27FC236}">
+                  <a16:creationId xmlns:a16="http://schemas.microsoft.com/office/drawing/2014/main" id="{AB59D29A-1EF9-2987-FF30-AE979FFFCF2E}"/>
+                </a:ext>
+              </a:extLst>
+            </p:cNvPr>
+            <p:cNvGrpSpPr/>
+            <p:nvPr/>
+          </p:nvGrpSpPr>
+          <p:grpSpPr>
+            <a:xfrm>
+              <a:off x="293462" y="9708209"/>
+              <a:ext cx="11273530" cy="7689140"/>
+              <a:chOff x="272558" y="5573824"/>
+              <a:chExt cx="11273530" cy="7689140"/>
+            </a:xfrm>
+          </p:grpSpPr>
+          <p:graphicFrame>
+            <p:nvGraphicFramePr>
+              <p:cNvPr id="14" name="Google Shape;116;p4">
+                <a:extLst>
+                  <a:ext uri="{FF2B5EF4-FFF2-40B4-BE49-F238E27FC236}">
+                    <a16:creationId xmlns:a16="http://schemas.microsoft.com/office/drawing/2014/main" id="{56F9B1C2-D9C1-75DA-BFAC-38CC49A9F9DC}"/>
+                  </a:ext>
+                </a:extLst>
+              </p:cNvPr>
+              <p:cNvGraphicFramePr/>
+              <p:nvPr>
+                <p:extLst>
+                  <p:ext uri="{D42A27DB-BD31-4B8C-83A1-F6EECF244321}">
+                    <p14:modId xmlns:p14="http://schemas.microsoft.com/office/powerpoint/2010/main" val="1722915679"/>
+                  </p:ext>
+                </p:extLst>
+              </p:nvPr>
+            </p:nvGraphicFramePr>
+            <p:xfrm>
+              <a:off x="8477256" y="5573824"/>
+              <a:ext cx="3068832" cy="2154560"/>
+            </p:xfrm>
+            <a:graphic>
+              <a:graphicData uri="http://schemas.openxmlformats.org/drawingml/2006/table">
+                <a:tbl>
+                  <a:tblPr firstRow="1" bandRow="1">
+                    <a:noFill/>
+                  </a:tblPr>
+                  <a:tblGrid>
+                    <a:gridCol w="2182470">
+                      <a:extLst>
+                        <a:ext uri="{9D8B030D-6E8A-4147-A177-3AD203B41FA5}">
+                          <a16:colId xmlns:a16="http://schemas.microsoft.com/office/drawing/2014/main" val="20000"/>
+                        </a:ext>
+                      </a:extLst>
+                    </a:gridCol>
+                    <a:gridCol w="1401065">
+                      <a:extLst>
+                        <a:ext uri="{9D8B030D-6E8A-4147-A177-3AD203B41FA5}">
+                          <a16:colId xmlns:a16="http://schemas.microsoft.com/office/drawing/2014/main" val="20001"/>
+                        </a:ext>
+                      </a:extLst>
+                    </a:gridCol>
+                  </a:tblGrid>
+                  <a:tr h="506206">
+                    <a:tc>
+                      <a:txBody>
+                        <a:bodyPr/>
+                        <a:lstStyle/>
+                        <a:p>
+                          <a:pPr marL="0" marR="0" lvl="0" indent="0" algn="ctr" rtl="0">
+                            <a:lnSpc>
+                              <a:spcPct val="100000"/>
+                            </a:lnSpc>
+                            <a:spcBef>
+                              <a:spcPts val="0"/>
+                            </a:spcBef>
+                            <a:spcAft>
+                              <a:spcPts val="0"/>
+                            </a:spcAft>
+                            <a:buNone/>
+                          </a:pPr>
+                          <a:r>
+                            <a:rPr lang="en-US" sz="2400" u="none" strike="noStrike" cap="none" dirty="0">
+                              <a:solidFill>
+                                <a:schemeClr val="lt1"/>
+                              </a:solidFill>
+                              <a:latin typeface="+mj-lt"/>
+                            </a:rPr>
+                            <a:t>Site</a:t>
+                          </a:r>
+                          <a:endParaRPr sz="2400" dirty="0">
+                            <a:latin typeface="+mj-lt"/>
+                          </a:endParaRPr>
+                        </a:p>
+                      </a:txBody>
+                      <a:tcPr marL="91450" marR="91450" marT="45725" marB="45725">
+                        <a:lnL w="9525" cap="flat" cmpd="sng">
+                          <a:solidFill>
+                            <a:srgbClr val="242424"/>
+                          </a:solidFill>
+                          <a:prstDash val="solid"/>
+                          <a:round/>
+                          <a:headEnd type="none" w="sm" len="sm"/>
+                          <a:tailEnd type="none" w="sm" len="sm"/>
+                        </a:lnL>
+                        <a:lnR w="9525" cap="flat" cmpd="sng">
+                          <a:solidFill>
+                            <a:srgbClr val="242424"/>
+                          </a:solidFill>
+                          <a:prstDash val="solid"/>
+                          <a:round/>
+                          <a:headEnd type="none" w="sm" len="sm"/>
+                          <a:tailEnd type="none" w="sm" len="sm"/>
+                        </a:lnR>
+                        <a:lnT w="9525" cap="flat" cmpd="sng">
+                          <a:solidFill>
+                            <a:srgbClr val="242424"/>
+                          </a:solidFill>
+                          <a:prstDash val="solid"/>
+                          <a:round/>
+                          <a:headEnd type="none" w="sm" len="sm"/>
+                          <a:tailEnd type="none" w="sm" len="sm"/>
+                        </a:lnT>
+                        <a:lnB w="9525" cap="flat" cmpd="sng">
+                          <a:solidFill>
+                            <a:srgbClr val="242424"/>
+                          </a:solidFill>
+                          <a:prstDash val="solid"/>
+                          <a:round/>
+                          <a:headEnd type="none" w="sm" len="sm"/>
+                          <a:tailEnd type="none" w="sm" len="sm"/>
+                        </a:lnB>
+                        <a:solidFill>
+                          <a:srgbClr val="242424"/>
+                        </a:solidFill>
+                      </a:tcPr>
+                    </a:tc>
+                    <a:tc>
+                      <a:txBody>
+                        <a:bodyPr/>
+                        <a:lstStyle/>
+                        <a:p>
+                          <a:pPr marL="0" marR="0" lvl="0" indent="0" algn="ctr" rtl="0">
+                            <a:lnSpc>
+                              <a:spcPct val="100000"/>
+                            </a:lnSpc>
+                            <a:spcBef>
+                              <a:spcPts val="0"/>
+                            </a:spcBef>
+                            <a:spcAft>
+                              <a:spcPts val="0"/>
+                            </a:spcAft>
+                            <a:buNone/>
+                          </a:pPr>
+                          <a:r>
+                            <a:rPr lang="en-US" sz="2400" u="none" strike="noStrike" cap="none" dirty="0">
+                              <a:solidFill>
+                                <a:schemeClr val="lt1"/>
+                              </a:solidFill>
+                              <a:latin typeface="+mj-lt"/>
+                            </a:rPr>
+                            <a:t>Salinity</a:t>
+                          </a:r>
+                          <a:endParaRPr sz="2400" dirty="0">
+                            <a:latin typeface="+mj-lt"/>
+                          </a:endParaRPr>
+                        </a:p>
+                      </a:txBody>
+                      <a:tcPr marL="91450" marR="91450" marT="45725" marB="45725">
+                        <a:lnL w="9525" cap="flat" cmpd="sng">
+                          <a:solidFill>
+                            <a:srgbClr val="242424"/>
+                          </a:solidFill>
+                          <a:prstDash val="solid"/>
+                          <a:round/>
+                          <a:headEnd type="none" w="sm" len="sm"/>
+                          <a:tailEnd type="none" w="sm" len="sm"/>
+                        </a:lnL>
+                        <a:lnR w="9525" cap="flat" cmpd="sng">
+                          <a:solidFill>
+                            <a:srgbClr val="242424"/>
+                          </a:solidFill>
+                          <a:prstDash val="solid"/>
+                          <a:round/>
+                          <a:headEnd type="none" w="sm" len="sm"/>
+                          <a:tailEnd type="none" w="sm" len="sm"/>
+                        </a:lnR>
+                        <a:lnT w="9525" cap="flat" cmpd="sng">
+                          <a:solidFill>
+                            <a:srgbClr val="242424"/>
+                          </a:solidFill>
+                          <a:prstDash val="solid"/>
+                          <a:round/>
+                          <a:headEnd type="none" w="sm" len="sm"/>
+                          <a:tailEnd type="none" w="sm" len="sm"/>
+                        </a:lnT>
+                        <a:lnB w="9525" cap="flat" cmpd="sng">
+                          <a:solidFill>
+                            <a:srgbClr val="242424"/>
+                          </a:solidFill>
+                          <a:prstDash val="solid"/>
+                          <a:round/>
+                          <a:headEnd type="none" w="sm" len="sm"/>
+                          <a:tailEnd type="none" w="sm" len="sm"/>
+                        </a:lnB>
+                        <a:solidFill>
+                          <a:srgbClr val="242424"/>
+                        </a:solidFill>
+                      </a:tcPr>
+                    </a:tc>
+                    <a:extLst>
+                      <a:ext uri="{0D108BD9-81ED-4DB2-BD59-A6C34878D82A}">
+                        <a16:rowId xmlns:a16="http://schemas.microsoft.com/office/drawing/2014/main" val="10000"/>
+                      </a:ext>
+                    </a:extLst>
+                  </a:tr>
+                  <a:tr h="507454">
+                    <a:tc>
+                      <a:txBody>
+                        <a:bodyPr/>
+                        <a:lstStyle/>
+                        <a:p>
+                          <a:pPr marL="0" marR="0" lvl="0" indent="0" algn="ctr" rtl="0">
+                            <a:lnSpc>
+                              <a:spcPct val="100000"/>
+                            </a:lnSpc>
+                            <a:spcBef>
+                              <a:spcPts val="0"/>
+                            </a:spcBef>
+                            <a:spcAft>
+                              <a:spcPts val="0"/>
+                            </a:spcAft>
+                            <a:buNone/>
+                          </a:pPr>
+                          <a:r>
+                            <a:rPr lang="en-US" sz="2400" dirty="0">
+                              <a:latin typeface="+mj-lt"/>
+                            </a:rPr>
+                            <a:t>Sweethall</a:t>
+                          </a:r>
+                          <a:endParaRPr sz="2400" dirty="0">
+                            <a:latin typeface="+mj-lt"/>
+                          </a:endParaRPr>
+                        </a:p>
+                      </a:txBody>
+                      <a:tcPr marL="91450" marR="91450" marT="45725" marB="45725">
+                        <a:lnL w="9525" cap="flat" cmpd="sng">
+                          <a:solidFill>
+                            <a:srgbClr val="242424"/>
+                          </a:solidFill>
+                          <a:prstDash val="solid"/>
+                          <a:round/>
+                          <a:headEnd type="none" w="sm" len="sm"/>
+                          <a:tailEnd type="none" w="sm" len="sm"/>
+                        </a:lnL>
+                        <a:lnR w="9525" cap="flat" cmpd="sng">
+                          <a:solidFill>
+                            <a:srgbClr val="242424"/>
+                          </a:solidFill>
+                          <a:prstDash val="solid"/>
+                          <a:round/>
+                          <a:headEnd type="none" w="sm" len="sm"/>
+                          <a:tailEnd type="none" w="sm" len="sm"/>
+                        </a:lnR>
+                        <a:lnT w="9525" cap="flat" cmpd="sng">
+                          <a:solidFill>
+                            <a:srgbClr val="242424"/>
+                          </a:solidFill>
+                          <a:prstDash val="solid"/>
+                          <a:round/>
+                          <a:headEnd type="none" w="sm" len="sm"/>
+                          <a:tailEnd type="none" w="sm" len="sm"/>
+                        </a:lnT>
+                        <a:lnB w="9525" cap="flat" cmpd="sng">
+                          <a:solidFill>
+                            <a:srgbClr val="242424"/>
+                          </a:solidFill>
+                          <a:prstDash val="solid"/>
+                          <a:round/>
+                          <a:headEnd type="none" w="sm" len="sm"/>
+                          <a:tailEnd type="none" w="sm" len="sm"/>
+                        </a:lnB>
+                      </a:tcPr>
+                    </a:tc>
+                    <a:tc>
+                      <a:txBody>
+                        <a:bodyPr/>
+                        <a:lstStyle/>
+                        <a:p>
+                          <a:pPr marL="0" marR="0" lvl="0" indent="0" algn="ctr" rtl="0">
+                            <a:lnSpc>
+                              <a:spcPct val="100000"/>
+                            </a:lnSpc>
+                            <a:spcBef>
+                              <a:spcPts val="0"/>
+                            </a:spcBef>
+                            <a:spcAft>
+                              <a:spcPts val="0"/>
+                            </a:spcAft>
+                            <a:buNone/>
+                          </a:pPr>
+                          <a:r>
+                            <a:rPr lang="en-US" sz="2400" u="none" strike="noStrike" cap="none" dirty="0">
+                              <a:solidFill>
+                                <a:srgbClr val="000000"/>
+                              </a:solidFill>
+                              <a:latin typeface="+mj-lt"/>
+                            </a:rPr>
+                            <a:t>0-2</a:t>
+                          </a:r>
+                          <a:endParaRPr sz="2400" dirty="0">
+                            <a:latin typeface="+mj-lt"/>
+                          </a:endParaRPr>
+                        </a:p>
+                      </a:txBody>
+                      <a:tcPr marL="91450" marR="91450" marT="45725" marB="45725">
+                        <a:lnL w="9525" cap="flat" cmpd="sng">
+                          <a:solidFill>
+                            <a:srgbClr val="242424"/>
+                          </a:solidFill>
+                          <a:prstDash val="solid"/>
+                          <a:round/>
+                          <a:headEnd type="none" w="sm" len="sm"/>
+                          <a:tailEnd type="none" w="sm" len="sm"/>
+                        </a:lnL>
+                        <a:lnR w="9525" cap="flat" cmpd="sng">
+                          <a:solidFill>
+                            <a:srgbClr val="242424"/>
+                          </a:solidFill>
+                          <a:prstDash val="solid"/>
+                          <a:round/>
+                          <a:headEnd type="none" w="sm" len="sm"/>
+                          <a:tailEnd type="none" w="sm" len="sm"/>
+                        </a:lnR>
+                        <a:lnT w="9525" cap="flat" cmpd="sng">
+                          <a:solidFill>
+                            <a:srgbClr val="242424"/>
+                          </a:solidFill>
+                          <a:prstDash val="solid"/>
+                          <a:round/>
+                          <a:headEnd type="none" w="sm" len="sm"/>
+                          <a:tailEnd type="none" w="sm" len="sm"/>
+                        </a:lnT>
+                        <a:lnB w="9525" cap="flat" cmpd="sng">
+                          <a:solidFill>
+                            <a:srgbClr val="242424"/>
+                          </a:solidFill>
+                          <a:prstDash val="solid"/>
+                          <a:round/>
+                          <a:headEnd type="none" w="sm" len="sm"/>
+                          <a:tailEnd type="none" w="sm" len="sm"/>
+                        </a:lnB>
+                      </a:tcPr>
+                    </a:tc>
+                    <a:extLst>
+                      <a:ext uri="{0D108BD9-81ED-4DB2-BD59-A6C34878D82A}">
+                        <a16:rowId xmlns:a16="http://schemas.microsoft.com/office/drawing/2014/main" val="10001"/>
+                      </a:ext>
+                    </a:extLst>
+                  </a:tr>
+                  <a:tr h="506206">
+                    <a:tc>
+                      <a:txBody>
+                        <a:bodyPr/>
+                        <a:lstStyle/>
+                        <a:p>
+                          <a:pPr marL="0" marR="0" lvl="0" indent="0" algn="ctr" rtl="0">
+                            <a:lnSpc>
+                              <a:spcPct val="100000"/>
+                            </a:lnSpc>
+                            <a:spcBef>
+                              <a:spcPts val="0"/>
+                            </a:spcBef>
+                            <a:spcAft>
+                              <a:spcPts val="0"/>
+                            </a:spcAft>
+                            <a:buNone/>
+                          </a:pPr>
+                          <a:r>
+                            <a:rPr lang="en-US" sz="2400" u="none" strike="noStrike" cap="none" dirty="0">
+                              <a:solidFill>
+                                <a:srgbClr val="000000"/>
+                              </a:solidFill>
+                              <a:latin typeface="+mj-lt"/>
+                            </a:rPr>
+                            <a:t>GCReW</a:t>
+                          </a:r>
+                          <a:endParaRPr sz="2400" dirty="0">
+                            <a:latin typeface="+mj-lt"/>
+                          </a:endParaRPr>
+                        </a:p>
+                      </a:txBody>
+                      <a:tcPr marL="91450" marR="91450" marT="45725" marB="45725">
+                        <a:lnL w="9525" cap="flat" cmpd="sng">
+                          <a:solidFill>
+                            <a:srgbClr val="242424"/>
+                          </a:solidFill>
+                          <a:prstDash val="solid"/>
+                          <a:round/>
+                          <a:headEnd type="none" w="sm" len="sm"/>
+                          <a:tailEnd type="none" w="sm" len="sm"/>
+                        </a:lnL>
+                        <a:lnR w="9525" cap="flat" cmpd="sng">
+                          <a:solidFill>
+                            <a:srgbClr val="242424"/>
+                          </a:solidFill>
+                          <a:prstDash val="solid"/>
+                          <a:round/>
+                          <a:headEnd type="none" w="sm" len="sm"/>
+                          <a:tailEnd type="none" w="sm" len="sm"/>
+                        </a:lnR>
+                        <a:lnT w="9525" cap="flat" cmpd="sng">
+                          <a:solidFill>
+                            <a:srgbClr val="242424"/>
+                          </a:solidFill>
+                          <a:prstDash val="solid"/>
+                          <a:round/>
+                          <a:headEnd type="none" w="sm" len="sm"/>
+                          <a:tailEnd type="none" w="sm" len="sm"/>
+                        </a:lnT>
+                        <a:lnB w="9525" cap="flat" cmpd="sng">
+                          <a:solidFill>
+                            <a:srgbClr val="242424"/>
+                          </a:solidFill>
+                          <a:prstDash val="solid"/>
+                          <a:round/>
+                          <a:headEnd type="none" w="sm" len="sm"/>
+                          <a:tailEnd type="none" w="sm" len="sm"/>
+                        </a:lnB>
+                      </a:tcPr>
+                    </a:tc>
+                    <a:tc>
+                      <a:txBody>
+                        <a:bodyPr/>
+                        <a:lstStyle/>
+                        <a:p>
+                          <a:pPr marL="0" marR="0" lvl="0" indent="0" algn="ctr" rtl="0">
+                            <a:lnSpc>
+                              <a:spcPct val="100000"/>
+                            </a:lnSpc>
+                            <a:spcBef>
+                              <a:spcPts val="0"/>
+                            </a:spcBef>
+                            <a:spcAft>
+                              <a:spcPts val="0"/>
+                            </a:spcAft>
+                            <a:buNone/>
+                          </a:pPr>
+                          <a:r>
+                            <a:rPr lang="en-US" sz="2400" u="none" strike="noStrike" cap="none" dirty="0">
+                              <a:solidFill>
+                                <a:srgbClr val="000000"/>
+                              </a:solidFill>
+                              <a:latin typeface="+mj-lt"/>
+                            </a:rPr>
+                            <a:t>8-10</a:t>
+                          </a:r>
+                          <a:endParaRPr sz="2400" dirty="0">
+                            <a:latin typeface="+mj-lt"/>
+                          </a:endParaRPr>
+                        </a:p>
+                      </a:txBody>
+                      <a:tcPr marL="91450" marR="91450" marT="45725" marB="45725">
+                        <a:lnL w="9525" cap="flat" cmpd="sng">
+                          <a:solidFill>
+                            <a:srgbClr val="242424"/>
+                          </a:solidFill>
+                          <a:prstDash val="solid"/>
+                          <a:round/>
+                          <a:headEnd type="none" w="sm" len="sm"/>
+                          <a:tailEnd type="none" w="sm" len="sm"/>
+                        </a:lnL>
+                        <a:lnR w="9525" cap="flat" cmpd="sng">
+                          <a:solidFill>
+                            <a:srgbClr val="242424"/>
+                          </a:solidFill>
+                          <a:prstDash val="solid"/>
+                          <a:round/>
+                          <a:headEnd type="none" w="sm" len="sm"/>
+                          <a:tailEnd type="none" w="sm" len="sm"/>
+                        </a:lnR>
+                        <a:lnT w="9525" cap="flat" cmpd="sng">
+                          <a:solidFill>
+                            <a:srgbClr val="242424"/>
+                          </a:solidFill>
+                          <a:prstDash val="solid"/>
+                          <a:round/>
+                          <a:headEnd type="none" w="sm" len="sm"/>
+                          <a:tailEnd type="none" w="sm" len="sm"/>
+                        </a:lnT>
+                        <a:lnB w="9525" cap="flat" cmpd="sng">
+                          <a:solidFill>
+                            <a:srgbClr val="242424"/>
+                          </a:solidFill>
+                          <a:prstDash val="solid"/>
+                          <a:round/>
+                          <a:headEnd type="none" w="sm" len="sm"/>
+                          <a:tailEnd type="none" w="sm" len="sm"/>
+                        </a:lnB>
+                      </a:tcPr>
+                    </a:tc>
+                    <a:extLst>
+                      <a:ext uri="{0D108BD9-81ED-4DB2-BD59-A6C34878D82A}">
+                        <a16:rowId xmlns:a16="http://schemas.microsoft.com/office/drawing/2014/main" val="10002"/>
+                      </a:ext>
+                    </a:extLst>
+                  </a:tr>
+                  <a:tr h="0">
+                    <a:tc>
+                      <a:txBody>
+                        <a:bodyPr/>
+                        <a:lstStyle/>
+                        <a:p>
+                          <a:pPr marL="0" marR="0" lvl="0" indent="0" algn="ctr" rtl="0">
+                            <a:lnSpc>
+                              <a:spcPct val="100000"/>
+                            </a:lnSpc>
+                            <a:spcBef>
+                              <a:spcPts val="0"/>
+                            </a:spcBef>
+                            <a:spcAft>
+                              <a:spcPts val="0"/>
+                            </a:spcAft>
+                            <a:buNone/>
+                          </a:pPr>
+                          <a:r>
+                            <a:rPr lang="en-US" sz="2400" u="none" strike="noStrike" cap="none" dirty="0">
+                              <a:solidFill>
+                                <a:srgbClr val="000000"/>
+                              </a:solidFill>
+                              <a:latin typeface="+mj-lt"/>
+                            </a:rPr>
+                            <a:t>M</a:t>
+                          </a:r>
+                          <a:r>
+                            <a:rPr lang="en-US" sz="2400" dirty="0">
+                              <a:latin typeface="+mj-lt"/>
+                            </a:rPr>
+                            <a:t>oneyStump</a:t>
+                          </a:r>
+                          <a:endParaRPr sz="2400" dirty="0">
+                            <a:latin typeface="+mj-lt"/>
+                          </a:endParaRPr>
+                        </a:p>
+                      </a:txBody>
+                      <a:tcPr marL="91450" marR="91450" marT="45725" marB="45725">
+                        <a:lnL w="9525" cap="flat" cmpd="sng">
+                          <a:solidFill>
+                            <a:srgbClr val="242424"/>
+                          </a:solidFill>
+                          <a:prstDash val="solid"/>
+                          <a:round/>
+                          <a:headEnd type="none" w="sm" len="sm"/>
+                          <a:tailEnd type="none" w="sm" len="sm"/>
+                        </a:lnL>
+                        <a:lnR w="9525" cap="flat" cmpd="sng">
+                          <a:solidFill>
+                            <a:srgbClr val="242424"/>
+                          </a:solidFill>
+                          <a:prstDash val="solid"/>
+                          <a:round/>
+                          <a:headEnd type="none" w="sm" len="sm"/>
+                          <a:tailEnd type="none" w="sm" len="sm"/>
+                        </a:lnR>
+                        <a:lnT w="9525" cap="flat" cmpd="sng">
+                          <a:solidFill>
+                            <a:srgbClr val="242424"/>
+                          </a:solidFill>
+                          <a:prstDash val="solid"/>
+                          <a:round/>
+                          <a:headEnd type="none" w="sm" len="sm"/>
+                          <a:tailEnd type="none" w="sm" len="sm"/>
+                        </a:lnT>
+                        <a:lnB w="9525" cap="flat" cmpd="sng">
+                          <a:solidFill>
+                            <a:srgbClr val="242424"/>
+                          </a:solidFill>
+                          <a:prstDash val="solid"/>
+                          <a:round/>
+                          <a:headEnd type="none" w="sm" len="sm"/>
+                          <a:tailEnd type="none" w="sm" len="sm"/>
+                        </a:lnB>
+                      </a:tcPr>
+                    </a:tc>
+                    <a:tc>
+                      <a:txBody>
+                        <a:bodyPr/>
+                        <a:lstStyle/>
+                        <a:p>
+                          <a:pPr marL="0" marR="0" lvl="0" indent="0" algn="ctr" rtl="0">
+                            <a:lnSpc>
+                              <a:spcPct val="100000"/>
+                            </a:lnSpc>
+                            <a:spcBef>
+                              <a:spcPts val="0"/>
+                            </a:spcBef>
+                            <a:spcAft>
+                              <a:spcPts val="0"/>
+                            </a:spcAft>
+                            <a:buNone/>
+                          </a:pPr>
+                          <a:r>
+                            <a:rPr lang="en-US" sz="2400" u="none" strike="noStrike" cap="none">
+                              <a:solidFill>
+                                <a:srgbClr val="000000"/>
+                              </a:solidFill>
+                              <a:latin typeface="+mj-lt"/>
+                            </a:rPr>
+                            <a:t>8-10</a:t>
+                          </a:r>
+                          <a:endParaRPr sz="2400">
+                            <a:latin typeface="+mj-lt"/>
+                          </a:endParaRPr>
+                        </a:p>
+                      </a:txBody>
+                      <a:tcPr marL="91450" marR="91450" marT="45725" marB="45725">
+                        <a:lnL w="9525" cap="flat" cmpd="sng">
+                          <a:solidFill>
+                            <a:srgbClr val="242424"/>
+                          </a:solidFill>
+                          <a:prstDash val="solid"/>
+                          <a:round/>
+                          <a:headEnd type="none" w="sm" len="sm"/>
+                          <a:tailEnd type="none" w="sm" len="sm"/>
+                        </a:lnL>
+                        <a:lnR w="9525" cap="flat" cmpd="sng">
+                          <a:solidFill>
+                            <a:srgbClr val="242424"/>
+                          </a:solidFill>
+                          <a:prstDash val="solid"/>
+                          <a:round/>
+                          <a:headEnd type="none" w="sm" len="sm"/>
+                          <a:tailEnd type="none" w="sm" len="sm"/>
+                        </a:lnR>
+                        <a:lnT w="9525" cap="flat" cmpd="sng">
+                          <a:solidFill>
+                            <a:srgbClr val="242424"/>
+                          </a:solidFill>
+                          <a:prstDash val="solid"/>
+                          <a:round/>
+                          <a:headEnd type="none" w="sm" len="sm"/>
+                          <a:tailEnd type="none" w="sm" len="sm"/>
+                        </a:lnT>
+                        <a:lnB w="9525" cap="flat" cmpd="sng">
+                          <a:solidFill>
+                            <a:srgbClr val="242424"/>
+                          </a:solidFill>
+                          <a:prstDash val="solid"/>
+                          <a:round/>
+                          <a:headEnd type="none" w="sm" len="sm"/>
+                          <a:tailEnd type="none" w="sm" len="sm"/>
+                        </a:lnB>
+                      </a:tcPr>
+                    </a:tc>
+                    <a:extLst>
+                      <a:ext uri="{0D108BD9-81ED-4DB2-BD59-A6C34878D82A}">
+                        <a16:rowId xmlns:a16="http://schemas.microsoft.com/office/drawing/2014/main" val="10003"/>
+                      </a:ext>
+                    </a:extLst>
+                  </a:tr>
+                  <a:tr h="895585">
+                    <a:tc>
+                      <a:txBody>
+                        <a:bodyPr/>
+                        <a:lstStyle/>
+                        <a:p>
+                          <a:pPr marL="0" marR="0" lvl="0" indent="0" algn="ctr" rtl="0">
+                            <a:lnSpc>
+                              <a:spcPct val="100000"/>
+                            </a:lnSpc>
+                            <a:spcBef>
+                              <a:spcPts val="0"/>
+                            </a:spcBef>
+                            <a:spcAft>
+                              <a:spcPts val="0"/>
+                            </a:spcAft>
+                            <a:buNone/>
+                          </a:pPr>
+                          <a:r>
+                            <a:rPr lang="en-US" sz="2400" u="none" strike="noStrike" cap="none" dirty="0">
+                              <a:solidFill>
+                                <a:srgbClr val="000000"/>
+                              </a:solidFill>
+                              <a:latin typeface="+mj-lt"/>
+                            </a:rPr>
+                            <a:t>G</a:t>
+                          </a:r>
+                          <a:r>
+                            <a:rPr lang="en-US" sz="2400" dirty="0">
+                              <a:latin typeface="+mj-lt"/>
+                            </a:rPr>
+                            <a:t>oodwin Islands</a:t>
+                          </a:r>
+                          <a:endParaRPr sz="2400" dirty="0">
+                            <a:latin typeface="+mj-lt"/>
+                          </a:endParaRPr>
+                        </a:p>
+                      </a:txBody>
+                      <a:tcPr marL="91450" marR="91450" marT="45725" marB="45725">
+                        <a:lnL w="9525" cap="flat" cmpd="sng">
+                          <a:solidFill>
+                            <a:srgbClr val="242424"/>
+                          </a:solidFill>
+                          <a:prstDash val="solid"/>
+                          <a:round/>
+                          <a:headEnd type="none" w="sm" len="sm"/>
+                          <a:tailEnd type="none" w="sm" len="sm"/>
+                        </a:lnL>
+                        <a:lnR w="9525" cap="flat" cmpd="sng">
+                          <a:solidFill>
+                            <a:srgbClr val="242424"/>
+                          </a:solidFill>
+                          <a:prstDash val="solid"/>
+                          <a:round/>
+                          <a:headEnd type="none" w="sm" len="sm"/>
+                          <a:tailEnd type="none" w="sm" len="sm"/>
+                        </a:lnR>
+                        <a:lnT w="9525" cap="flat" cmpd="sng">
+                          <a:solidFill>
+                            <a:srgbClr val="242424"/>
+                          </a:solidFill>
+                          <a:prstDash val="solid"/>
+                          <a:round/>
+                          <a:headEnd type="none" w="sm" len="sm"/>
+                          <a:tailEnd type="none" w="sm" len="sm"/>
+                        </a:lnT>
+                        <a:lnB w="9525" cap="flat" cmpd="sng">
+                          <a:solidFill>
+                            <a:srgbClr val="242424"/>
+                          </a:solidFill>
+                          <a:prstDash val="solid"/>
+                          <a:round/>
+                          <a:headEnd type="none" w="sm" len="sm"/>
+                          <a:tailEnd type="none" w="sm" len="sm"/>
+                        </a:lnB>
+                      </a:tcPr>
+                    </a:tc>
+                    <a:tc>
+                      <a:txBody>
+                        <a:bodyPr/>
+                        <a:lstStyle/>
+                        <a:p>
+                          <a:pPr marL="0" marR="0" lvl="0" indent="0" algn="ctr" rtl="0">
+                            <a:lnSpc>
+                              <a:spcPct val="100000"/>
+                            </a:lnSpc>
+                            <a:spcBef>
+                              <a:spcPts val="0"/>
+                            </a:spcBef>
+                            <a:spcAft>
+                              <a:spcPts val="0"/>
+                            </a:spcAft>
+                            <a:buNone/>
+                          </a:pPr>
+                          <a:r>
+                            <a:rPr lang="en-US" sz="2400" u="none" strike="noStrike" cap="none" dirty="0">
+                              <a:solidFill>
+                                <a:srgbClr val="000000"/>
+                              </a:solidFill>
+                              <a:latin typeface="+mj-lt"/>
+                            </a:rPr>
+                            <a:t>18-20</a:t>
+                          </a:r>
+                          <a:endParaRPr sz="2400" dirty="0">
+                            <a:latin typeface="+mj-lt"/>
+                          </a:endParaRPr>
+                        </a:p>
+                      </a:txBody>
+                      <a:tcPr marL="91450" marR="91450" marT="45725" marB="45725">
+                        <a:lnL w="9525" cap="flat" cmpd="sng">
+                          <a:solidFill>
+                            <a:srgbClr val="242424"/>
+                          </a:solidFill>
+                          <a:prstDash val="solid"/>
+                          <a:round/>
+                          <a:headEnd type="none" w="sm" len="sm"/>
+                          <a:tailEnd type="none" w="sm" len="sm"/>
+                        </a:lnL>
+                        <a:lnR w="9525" cap="flat" cmpd="sng">
+                          <a:solidFill>
+                            <a:srgbClr val="242424"/>
+                          </a:solidFill>
+                          <a:prstDash val="solid"/>
+                          <a:round/>
+                          <a:headEnd type="none" w="sm" len="sm"/>
+                          <a:tailEnd type="none" w="sm" len="sm"/>
+                        </a:lnR>
+                        <a:lnT w="9525" cap="flat" cmpd="sng">
+                          <a:solidFill>
+                            <a:srgbClr val="242424"/>
+                          </a:solidFill>
+                          <a:prstDash val="solid"/>
+                          <a:round/>
+                          <a:headEnd type="none" w="sm" len="sm"/>
+                          <a:tailEnd type="none" w="sm" len="sm"/>
+                        </a:lnT>
+                        <a:lnB w="9525" cap="flat" cmpd="sng">
+                          <a:solidFill>
+                            <a:srgbClr val="242424"/>
+                          </a:solidFill>
+                          <a:prstDash val="solid"/>
+                          <a:round/>
+                          <a:headEnd type="none" w="sm" len="sm"/>
+                          <a:tailEnd type="none" w="sm" len="sm"/>
+                        </a:lnB>
+                      </a:tcPr>
+                    </a:tc>
+                    <a:extLst>
+                      <a:ext uri="{0D108BD9-81ED-4DB2-BD59-A6C34878D82A}">
+                        <a16:rowId xmlns:a16="http://schemas.microsoft.com/office/drawing/2014/main" val="10004"/>
+                      </a:ext>
+                    </a:extLst>
+                  </a:tr>
+                </a:tbl>
+              </a:graphicData>
+            </a:graphic>
+          </p:graphicFrame>
+          <p:grpSp>
+            <p:nvGrpSpPr>
+              <p:cNvPr id="15" name="Group 14">
+                <a:extLst>
+                  <a:ext uri="{FF2B5EF4-FFF2-40B4-BE49-F238E27FC236}">
+                    <a16:creationId xmlns:a16="http://schemas.microsoft.com/office/drawing/2014/main" id="{0E367648-4E89-A155-1A9E-15B8C3DF3038}"/>
+                  </a:ext>
+                </a:extLst>
+              </p:cNvPr>
+              <p:cNvGrpSpPr/>
+              <p:nvPr/>
+            </p:nvGrpSpPr>
+            <p:grpSpPr>
+              <a:xfrm>
+                <a:off x="272558" y="9198156"/>
+                <a:ext cx="11002382" cy="4064808"/>
+                <a:chOff x="928742" y="15582937"/>
+                <a:chExt cx="9627773" cy="3179751"/>
+              </a:xfrm>
+            </p:grpSpPr>
+            <p:sp>
+              <p:nvSpPr>
+                <p:cNvPr id="16" name="TextBox 15">
+                  <a:extLst>
+                    <a:ext uri="{FF2B5EF4-FFF2-40B4-BE49-F238E27FC236}">
+                      <a16:creationId xmlns:a16="http://schemas.microsoft.com/office/drawing/2014/main" id="{E0D9E24C-C2DB-2D0E-CA54-54F25AC8CC0A}"/>
+                    </a:ext>
+                  </a:extLst>
+                </p:cNvPr>
+                <p:cNvSpPr txBox="1"/>
+                <p:nvPr/>
+              </p:nvSpPr>
+              <p:spPr>
+                <a:xfrm>
+                  <a:off x="5924325" y="18335237"/>
+                  <a:ext cx="2668307" cy="400881"/>
+                </a:xfrm>
+                <a:prstGeom prst="rect">
+                  <a:avLst/>
+                </a:prstGeom>
+                <a:noFill/>
+              </p:spPr>
+              <p:txBody>
+                <a:bodyPr wrap="square">
+                  <a:spAutoFit/>
+                </a:bodyPr>
+                <a:lstStyle/>
+                <a:p>
+                  <a:pPr algn="ctr"/>
+                  <a:r>
+                    <a:rPr lang="en-US" sz="3840" b="1" dirty="0">
+                      <a:solidFill>
+                        <a:srgbClr val="AD9335"/>
+                      </a:solidFill>
+                      <a:latin typeface="Arial" panose="020B0604020202020204" pitchFamily="34" charset="0"/>
+                    </a:rPr>
+                    <a:t>Transition </a:t>
+                  </a:r>
+                  <a:endParaRPr lang="en-US" sz="4676" dirty="0"/>
+                </a:p>
+              </p:txBody>
+            </p:sp>
+            <p:sp>
+              <p:nvSpPr>
+                <p:cNvPr id="17" name="TextBox 16">
+                  <a:extLst>
+                    <a:ext uri="{FF2B5EF4-FFF2-40B4-BE49-F238E27FC236}">
+                      <a16:creationId xmlns:a16="http://schemas.microsoft.com/office/drawing/2014/main" id="{7409ABA5-80CE-1A6D-86E3-23678C18136F}"/>
+                    </a:ext>
+                  </a:extLst>
+                </p:cNvPr>
+                <p:cNvSpPr txBox="1"/>
+                <p:nvPr/>
+              </p:nvSpPr>
+              <p:spPr>
+                <a:xfrm>
+                  <a:off x="3615900" y="18327135"/>
+                  <a:ext cx="2015164" cy="400881"/>
+                </a:xfrm>
+                <a:prstGeom prst="rect">
+                  <a:avLst/>
+                </a:prstGeom>
+                <a:noFill/>
+              </p:spPr>
+              <p:txBody>
+                <a:bodyPr wrap="square">
+                  <a:spAutoFit/>
+                </a:bodyPr>
+                <a:lstStyle/>
+                <a:p>
+                  <a:pPr algn="ctr"/>
+                  <a:r>
+                    <a:rPr lang="en-US" sz="3840" b="1" dirty="0">
+                      <a:solidFill>
+                        <a:srgbClr val="7F7F7F"/>
+                      </a:solidFill>
+                      <a:latin typeface="Arial" panose="020B0604020202020204" pitchFamily="34" charset="0"/>
+                    </a:rPr>
+                    <a:t>Upland </a:t>
+                  </a:r>
+                  <a:endParaRPr lang="en-US" sz="4676" dirty="0"/>
+                </a:p>
+              </p:txBody>
+            </p:sp>
+            <p:sp>
+              <p:nvSpPr>
+                <p:cNvPr id="18" name="TextBox 17">
+                  <a:extLst>
+                    <a:ext uri="{FF2B5EF4-FFF2-40B4-BE49-F238E27FC236}">
+                      <a16:creationId xmlns:a16="http://schemas.microsoft.com/office/drawing/2014/main" id="{920C9DEA-E578-5373-18E5-350865C7777A}"/>
+                    </a:ext>
+                  </a:extLst>
+                </p:cNvPr>
+                <p:cNvSpPr txBox="1"/>
+                <p:nvPr/>
+              </p:nvSpPr>
+              <p:spPr>
+                <a:xfrm>
+                  <a:off x="8346715" y="18354655"/>
+                  <a:ext cx="2209800" cy="400881"/>
+                </a:xfrm>
+                <a:prstGeom prst="rect">
+                  <a:avLst/>
+                </a:prstGeom>
+                <a:noFill/>
+              </p:spPr>
+              <p:txBody>
+                <a:bodyPr wrap="square">
+                  <a:spAutoFit/>
+                </a:bodyPr>
+                <a:lstStyle/>
+                <a:p>
+                  <a:pPr algn="ctr"/>
+                  <a:r>
+                    <a:rPr lang="en-US" sz="3840" b="1" dirty="0">
+                      <a:solidFill>
+                        <a:srgbClr val="214A2B"/>
+                      </a:solidFill>
+                      <a:latin typeface="Arial" panose="020B0604020202020204" pitchFamily="34" charset="0"/>
+                    </a:rPr>
+                    <a:t>Wetland </a:t>
+                  </a:r>
+                  <a:endParaRPr lang="en-US" sz="4676" dirty="0"/>
+                </a:p>
+              </p:txBody>
+            </p:sp>
+            <p:grpSp>
+              <p:nvGrpSpPr>
+                <p:cNvPr id="19" name="Group 18">
+                  <a:extLst>
+                    <a:ext uri="{FF2B5EF4-FFF2-40B4-BE49-F238E27FC236}">
+                      <a16:creationId xmlns:a16="http://schemas.microsoft.com/office/drawing/2014/main" id="{30FB1E63-A86C-68D1-1DB5-8CC770A44E5C}"/>
+                    </a:ext>
+                  </a:extLst>
+                </p:cNvPr>
+                <p:cNvGrpSpPr/>
+                <p:nvPr/>
+              </p:nvGrpSpPr>
+              <p:grpSpPr>
+                <a:xfrm>
+                  <a:off x="928742" y="15582937"/>
+                  <a:ext cx="9424200" cy="3179751"/>
+                  <a:chOff x="899080" y="7578118"/>
+                  <a:chExt cx="9424200" cy="3179751"/>
+                </a:xfrm>
+              </p:grpSpPr>
+              <p:pic>
+                <p:nvPicPr>
+                  <p:cNvPr id="20" name="Picture 14">
+                    <a:extLst>
+                      <a:ext uri="{FF2B5EF4-FFF2-40B4-BE49-F238E27FC236}">
+                        <a16:creationId xmlns:a16="http://schemas.microsoft.com/office/drawing/2014/main" id="{A51D45FF-0829-9D8E-6064-0F3C7D46D2B7}"/>
+                      </a:ext>
+                    </a:extLst>
+                  </p:cNvPr>
+                  <p:cNvPicPr>
+                    <a:picLocks noChangeAspect="1" noChangeArrowheads="1"/>
+                  </p:cNvPicPr>
+                  <p:nvPr/>
+                </p:nvPicPr>
+                <p:blipFill rotWithShape="1">
+                  <a:blip r:embed="rId3">
+                    <a:extLst>
+                      <a:ext uri="{28A0092B-C50C-407E-A947-70E740481C1C}">
+                        <a14:useLocalDpi xmlns:a14="http://schemas.microsoft.com/office/drawing/2010/main" val="0"/>
+                      </a:ext>
+                    </a:extLst>
+                  </a:blip>
+                  <a:srcRect l="23500" t="37555" r="55500" b="10000"/>
+                  <a:stretch/>
+                </p:blipFill>
+                <p:spPr bwMode="auto">
+                  <a:xfrm>
+                    <a:off x="899080" y="7578118"/>
+                    <a:ext cx="2263551" cy="3179751"/>
+                  </a:xfrm>
+                  <a:prstGeom prst="rect">
+                    <a:avLst/>
+                  </a:prstGeom>
+                  <a:noFill/>
+                  <a:ln>
+                    <a:solidFill>
+                      <a:schemeClr val="tx1"/>
+                    </a:solidFill>
+                  </a:ln>
+                  <a:extLst>
+                    <a:ext uri="{909E8E84-426E-40DD-AFC4-6F175D3DCCD1}">
+                      <a14:hiddenFill xmlns:a14="http://schemas.microsoft.com/office/drawing/2010/main">
+                        <a:solidFill>
+                          <a:srgbClr val="FFFFFF"/>
+                        </a:solidFill>
+                      </a14:hiddenFill>
+                    </a:ext>
+                  </a:extLst>
+                </p:spPr>
+              </p:pic>
+              <p:pic>
+                <p:nvPicPr>
+                  <p:cNvPr id="21" name="Picture 16">
+                    <a:extLst>
+                      <a:ext uri="{FF2B5EF4-FFF2-40B4-BE49-F238E27FC236}">
+                        <a16:creationId xmlns:a16="http://schemas.microsoft.com/office/drawing/2014/main" id="{BAB34A5F-B61B-A146-60C0-71DDB4DF1004}"/>
+                      </a:ext>
+                    </a:extLst>
+                  </p:cNvPr>
+                  <p:cNvPicPr>
+                    <a:picLocks noChangeAspect="1" noChangeArrowheads="1"/>
+                  </p:cNvPicPr>
+                  <p:nvPr/>
+                </p:nvPicPr>
+                <p:blipFill rotWithShape="1">
+                  <a:blip r:embed="rId4" cstate="print">
+                    <a:extLst>
+                      <a:ext uri="{28A0092B-C50C-407E-A947-70E740481C1C}">
+                        <a14:useLocalDpi xmlns:a14="http://schemas.microsoft.com/office/drawing/2010/main" val="0"/>
+                      </a:ext>
+                    </a:extLst>
+                  </a:blip>
+                  <a:srcRect t="28816" b="28777"/>
+                  <a:stretch/>
+                </p:blipFill>
+                <p:spPr bwMode="auto">
+                  <a:xfrm>
+                    <a:off x="3657600" y="8315169"/>
+                    <a:ext cx="6553200" cy="1851522"/>
+                  </a:xfrm>
+                  <a:prstGeom prst="rect">
+                    <a:avLst/>
+                  </a:prstGeom>
+                  <a:noFill/>
+                  <a:extLst>
+                    <a:ext uri="{909E8E84-426E-40DD-AFC4-6F175D3DCCD1}">
+                      <a14:hiddenFill xmlns:a14="http://schemas.microsoft.com/office/drawing/2010/main">
+                        <a:solidFill>
+                          <a:srgbClr val="FFFFFF"/>
+                        </a:solidFill>
+                      </a14:hiddenFill>
+                    </a:ext>
+                  </a:extLst>
+                </p:spPr>
+              </p:pic>
+              <p:sp>
+                <p:nvSpPr>
+                  <p:cNvPr id="22" name="Isosceles Triangle 9">
+                    <a:extLst>
+                      <a:ext uri="{FF2B5EF4-FFF2-40B4-BE49-F238E27FC236}">
+                        <a16:creationId xmlns:a16="http://schemas.microsoft.com/office/drawing/2014/main" id="{F9695197-0372-36BD-CF7D-7C6BADCA7DB9}"/>
+                      </a:ext>
+                    </a:extLst>
+                  </p:cNvPr>
+                  <p:cNvSpPr/>
+                  <p:nvPr/>
+                </p:nvSpPr>
+                <p:spPr>
+                  <a:xfrm rot="16200000">
+                    <a:off x="2022821" y="8767998"/>
+                    <a:ext cx="2072359" cy="965647"/>
+                  </a:xfrm>
+                  <a:custGeom>
+                    <a:avLst/>
+                    <a:gdLst>
+                      <a:gd name="connsiteX0" fmla="*/ 0 w 1858996"/>
+                      <a:gd name="connsiteY0" fmla="*/ 1119526 h 1119526"/>
+                      <a:gd name="connsiteX1" fmla="*/ 929498 w 1858996"/>
+                      <a:gd name="connsiteY1" fmla="*/ 0 h 1119526"/>
+                      <a:gd name="connsiteX2" fmla="*/ 1858996 w 1858996"/>
+                      <a:gd name="connsiteY2" fmla="*/ 1119526 h 1119526"/>
+                      <a:gd name="connsiteX3" fmla="*/ 0 w 1858996"/>
+                      <a:gd name="connsiteY3" fmla="*/ 1119526 h 1119526"/>
+                      <a:gd name="connsiteX0" fmla="*/ 0 w 1858996"/>
+                      <a:gd name="connsiteY0" fmla="*/ 1081426 h 1081426"/>
+                      <a:gd name="connsiteX1" fmla="*/ 1405748 w 1858996"/>
+                      <a:gd name="connsiteY1" fmla="*/ 0 h 1081426"/>
+                      <a:gd name="connsiteX2" fmla="*/ 1858996 w 1858996"/>
+                      <a:gd name="connsiteY2" fmla="*/ 1081426 h 1081426"/>
+                      <a:gd name="connsiteX3" fmla="*/ 0 w 1858996"/>
+                      <a:gd name="connsiteY3" fmla="*/ 1081426 h 1081426"/>
+                    </a:gdLst>
+                    <a:ahLst/>
+                    <a:cxnLst>
+                      <a:cxn ang="0">
+                        <a:pos x="connsiteX0" y="connsiteY0"/>
+                      </a:cxn>
+                      <a:cxn ang="0">
+                        <a:pos x="connsiteX1" y="connsiteY1"/>
+                      </a:cxn>
+                      <a:cxn ang="0">
+                        <a:pos x="connsiteX2" y="connsiteY2"/>
+                      </a:cxn>
+                      <a:cxn ang="0">
+                        <a:pos x="connsiteX3" y="connsiteY3"/>
+                      </a:cxn>
+                    </a:cxnLst>
+                    <a:rect l="l" t="t" r="r" b="b"/>
+                    <a:pathLst>
+                      <a:path w="1858996" h="1081426">
+                        <a:moveTo>
+                          <a:pt x="0" y="1081426"/>
+                        </a:moveTo>
+                        <a:lnTo>
+                          <a:pt x="1405748" y="0"/>
+                        </a:lnTo>
+                        <a:lnTo>
+                          <a:pt x="1858996" y="1081426"/>
+                        </a:lnTo>
+                        <a:lnTo>
+                          <a:pt x="0" y="1081426"/>
+                        </a:lnTo>
+                        <a:close/>
+                      </a:path>
+                    </a:pathLst>
+                  </a:custGeom>
+                  <a:solidFill>
+                    <a:srgbClr val="A6A6A6">
+                      <a:alpha val="60000"/>
+                    </a:srgbClr>
+                  </a:solidFill>
+                  <a:ln>
+                    <a:solidFill>
+                      <a:schemeClr val="tx1">
+                        <a:lumMod val="50000"/>
+                        <a:lumOff val="50000"/>
+                      </a:schemeClr>
+                    </a:solidFill>
+                  </a:ln>
+                </p:spPr>
+                <p:style>
+                  <a:lnRef idx="2">
+                    <a:schemeClr val="accent1">
+                      <a:shade val="50000"/>
+                    </a:schemeClr>
+                  </a:lnRef>
+                  <a:fillRef idx="1">
+                    <a:schemeClr val="accent1"/>
+                  </a:fillRef>
+                  <a:effectRef idx="0">
+                    <a:schemeClr val="accent1"/>
+                  </a:effectRef>
+                  <a:fontRef idx="minor">
+                    <a:schemeClr val="lt1"/>
+                  </a:fontRef>
+                </p:style>
+                <p:txBody>
+                  <a:bodyPr rtlCol="0" anchor="ctr"/>
+                  <a:lstStyle/>
+                  <a:p>
+                    <a:pPr algn="ctr"/>
+                    <a:endParaRPr lang="en-US" sz="4676"/>
+                  </a:p>
+                </p:txBody>
+              </p:sp>
+              <p:sp>
+                <p:nvSpPr>
+                  <p:cNvPr id="23" name="Rectangle 22">
+                    <a:extLst>
+                      <a:ext uri="{FF2B5EF4-FFF2-40B4-BE49-F238E27FC236}">
+                        <a16:creationId xmlns:a16="http://schemas.microsoft.com/office/drawing/2014/main" id="{ABA8B7CC-1FE4-251F-79DA-0A05B8700085}"/>
+                      </a:ext>
+                    </a:extLst>
+                  </p:cNvPr>
+                  <p:cNvSpPr/>
+                  <p:nvPr/>
+                </p:nvSpPr>
+                <p:spPr>
+                  <a:xfrm>
+                    <a:off x="3545120" y="8214640"/>
+                    <a:ext cx="2007627" cy="2072359"/>
+                  </a:xfrm>
+                  <a:prstGeom prst="rect">
+                    <a:avLst/>
+                  </a:prstGeom>
+                  <a:noFill/>
+                  <a:ln w="57150">
+                    <a:solidFill>
+                      <a:srgbClr val="777469"/>
+                    </a:solidFill>
+                  </a:ln>
+                </p:spPr>
+                <p:style>
+                  <a:lnRef idx="2">
+                    <a:schemeClr val="accent1">
+                      <a:shade val="50000"/>
+                    </a:schemeClr>
+                  </a:lnRef>
+                  <a:fillRef idx="1">
+                    <a:schemeClr val="accent1"/>
+                  </a:fillRef>
+                  <a:effectRef idx="0">
+                    <a:schemeClr val="accent1"/>
+                  </a:effectRef>
+                  <a:fontRef idx="minor">
+                    <a:schemeClr val="lt1"/>
+                  </a:fontRef>
+                </p:style>
+                <p:txBody>
+                  <a:bodyPr rtlCol="0" anchor="ctr"/>
+                  <a:lstStyle/>
+                  <a:p>
+                    <a:pPr algn="ctr"/>
+                    <a:endParaRPr lang="en-US" sz="4676"/>
+                  </a:p>
+                </p:txBody>
+              </p:sp>
+              <p:sp>
+                <p:nvSpPr>
+                  <p:cNvPr id="24" name="Rectangle 23">
+                    <a:extLst>
+                      <a:ext uri="{FF2B5EF4-FFF2-40B4-BE49-F238E27FC236}">
+                        <a16:creationId xmlns:a16="http://schemas.microsoft.com/office/drawing/2014/main" id="{D28644AF-2150-F79C-87AB-D9DE2536E38D}"/>
+                      </a:ext>
+                    </a:extLst>
+                  </p:cNvPr>
+                  <p:cNvSpPr/>
+                  <p:nvPr/>
+                </p:nvSpPr>
+                <p:spPr>
+                  <a:xfrm>
+                    <a:off x="6079668" y="8214641"/>
+                    <a:ext cx="2209801" cy="2072359"/>
+                  </a:xfrm>
+                  <a:prstGeom prst="rect">
+                    <a:avLst/>
+                  </a:prstGeom>
+                  <a:noFill/>
+                  <a:ln w="57150">
+                    <a:solidFill>
+                      <a:srgbClr val="AD9335"/>
+                    </a:solidFill>
+                  </a:ln>
+                </p:spPr>
+                <p:style>
+                  <a:lnRef idx="2">
+                    <a:schemeClr val="accent1">
+                      <a:shade val="50000"/>
+                    </a:schemeClr>
+                  </a:lnRef>
+                  <a:fillRef idx="1">
+                    <a:schemeClr val="accent1"/>
+                  </a:fillRef>
+                  <a:effectRef idx="0">
+                    <a:schemeClr val="accent1"/>
+                  </a:effectRef>
+                  <a:fontRef idx="minor">
+                    <a:schemeClr val="lt1"/>
+                  </a:fontRef>
+                </p:style>
+                <p:txBody>
+                  <a:bodyPr rtlCol="0" anchor="ctr"/>
+                  <a:lstStyle/>
+                  <a:p>
+                    <a:pPr algn="ctr"/>
+                    <a:endParaRPr lang="en-US" sz="4676"/>
+                  </a:p>
+                </p:txBody>
+              </p:sp>
+              <p:sp>
+                <p:nvSpPr>
+                  <p:cNvPr id="25" name="Rectangle 24">
+                    <a:extLst>
+                      <a:ext uri="{FF2B5EF4-FFF2-40B4-BE49-F238E27FC236}">
+                        <a16:creationId xmlns:a16="http://schemas.microsoft.com/office/drawing/2014/main" id="{4C5B3312-2479-3346-1E6F-62ED14C1564E}"/>
+                      </a:ext>
+                    </a:extLst>
+                  </p:cNvPr>
+                  <p:cNvSpPr/>
+                  <p:nvPr/>
+                </p:nvSpPr>
+                <p:spPr>
+                  <a:xfrm>
+                    <a:off x="8516357" y="8214641"/>
+                    <a:ext cx="1806923" cy="2072359"/>
+                  </a:xfrm>
+                  <a:prstGeom prst="rect">
+                    <a:avLst/>
+                  </a:prstGeom>
+                  <a:noFill/>
+                  <a:ln w="57150">
+                    <a:solidFill>
+                      <a:srgbClr val="214A2B"/>
+                    </a:solidFill>
+                  </a:ln>
+                </p:spPr>
+                <p:style>
+                  <a:lnRef idx="2">
+                    <a:schemeClr val="accent1">
+                      <a:shade val="50000"/>
+                    </a:schemeClr>
+                  </a:lnRef>
+                  <a:fillRef idx="1">
+                    <a:schemeClr val="accent1"/>
+                  </a:fillRef>
+                  <a:effectRef idx="0">
+                    <a:schemeClr val="accent1"/>
+                  </a:effectRef>
+                  <a:fontRef idx="minor">
+                    <a:schemeClr val="lt1"/>
+                  </a:fontRef>
+                </p:style>
+                <p:txBody>
+                  <a:bodyPr rtlCol="0" anchor="ctr"/>
+                  <a:lstStyle/>
+                  <a:p>
+                    <a:pPr algn="ctr"/>
+                    <a:endParaRPr lang="en-US" sz="4676"/>
+                  </a:p>
+                </p:txBody>
+              </p:sp>
+              <p:sp>
+                <p:nvSpPr>
+                  <p:cNvPr id="26" name="TextBox 25">
+                    <a:extLst>
+                      <a:ext uri="{FF2B5EF4-FFF2-40B4-BE49-F238E27FC236}">
+                        <a16:creationId xmlns:a16="http://schemas.microsoft.com/office/drawing/2014/main" id="{51528697-AA68-29FF-9215-D838167DF3EF}"/>
+                      </a:ext>
+                    </a:extLst>
+                  </p:cNvPr>
+                  <p:cNvSpPr txBox="1"/>
+                  <p:nvPr/>
+                </p:nvSpPr>
+                <p:spPr>
+                  <a:xfrm>
+                    <a:off x="1101908" y="7662833"/>
+                    <a:ext cx="1750958" cy="249197"/>
+                  </a:xfrm>
+                  <a:prstGeom prst="rect">
+                    <a:avLst/>
+                  </a:prstGeom>
+                  <a:noFill/>
+                </p:spPr>
+                <p:txBody>
+                  <a:bodyPr wrap="square" rtlCol="0">
+                    <a:spAutoFit/>
+                  </a:bodyPr>
+                  <a:lstStyle/>
+                  <a:p>
+                    <a:r>
+                      <a:rPr lang="en-US" sz="2160" dirty="0"/>
+                      <a:t>GCReW</a:t>
+                    </a:r>
+                  </a:p>
+                </p:txBody>
+              </p:sp>
+              <p:sp>
+                <p:nvSpPr>
+                  <p:cNvPr id="27" name="TextBox 26">
+                    <a:extLst>
+                      <a:ext uri="{FF2B5EF4-FFF2-40B4-BE49-F238E27FC236}">
+                        <a16:creationId xmlns:a16="http://schemas.microsoft.com/office/drawing/2014/main" id="{7B372F78-9019-1A74-3F3C-916FFA4FFDC1}"/>
+                      </a:ext>
+                    </a:extLst>
+                  </p:cNvPr>
+                  <p:cNvSpPr txBox="1"/>
+                  <p:nvPr/>
+                </p:nvSpPr>
+                <p:spPr>
+                  <a:xfrm>
+                    <a:off x="1261457" y="8174021"/>
+                    <a:ext cx="1750958" cy="249197"/>
+                  </a:xfrm>
+                  <a:prstGeom prst="rect">
+                    <a:avLst/>
+                  </a:prstGeom>
+                  <a:noFill/>
+                </p:spPr>
+                <p:txBody>
+                  <a:bodyPr wrap="square" rtlCol="0">
+                    <a:spAutoFit/>
+                  </a:bodyPr>
+                  <a:lstStyle/>
+                  <a:p>
+                    <a:r>
+                      <a:rPr lang="en-US" sz="2160" dirty="0"/>
+                      <a:t>Money Stump</a:t>
+                    </a:r>
+                  </a:p>
+                </p:txBody>
+              </p:sp>
+              <p:sp>
+                <p:nvSpPr>
+                  <p:cNvPr id="28" name="TextBox 27">
+                    <a:extLst>
+                      <a:ext uri="{FF2B5EF4-FFF2-40B4-BE49-F238E27FC236}">
+                        <a16:creationId xmlns:a16="http://schemas.microsoft.com/office/drawing/2014/main" id="{BFE2514F-65F7-C634-5697-EA483C6F84BF}"/>
+                      </a:ext>
+                    </a:extLst>
+                  </p:cNvPr>
+                  <p:cNvSpPr txBox="1"/>
+                  <p:nvPr/>
+                </p:nvSpPr>
+                <p:spPr>
+                  <a:xfrm>
+                    <a:off x="1778391" y="9662022"/>
+                    <a:ext cx="1750958" cy="249197"/>
+                  </a:xfrm>
+                  <a:prstGeom prst="rect">
+                    <a:avLst/>
+                  </a:prstGeom>
+                  <a:noFill/>
+                </p:spPr>
+                <p:txBody>
+                  <a:bodyPr wrap="square" rtlCol="0">
+                    <a:spAutoFit/>
+                  </a:bodyPr>
+                  <a:lstStyle/>
+                  <a:p>
+                    <a:r>
+                      <a:rPr lang="en-US" sz="2160" dirty="0"/>
+                      <a:t>Goodwin Islands</a:t>
+                    </a:r>
+                  </a:p>
+                </p:txBody>
+              </p:sp>
+              <p:sp>
+                <p:nvSpPr>
+                  <p:cNvPr id="29" name="TextBox 28">
+                    <a:extLst>
+                      <a:ext uri="{FF2B5EF4-FFF2-40B4-BE49-F238E27FC236}">
+                        <a16:creationId xmlns:a16="http://schemas.microsoft.com/office/drawing/2014/main" id="{C32DDAA2-6DBA-FC18-4A38-004EDC74ED07}"/>
+                      </a:ext>
+                    </a:extLst>
+                  </p:cNvPr>
+                  <p:cNvSpPr txBox="1"/>
+                  <p:nvPr/>
+                </p:nvSpPr>
+                <p:spPr>
+                  <a:xfrm>
+                    <a:off x="1014980" y="9118251"/>
+                    <a:ext cx="1750958" cy="249197"/>
+                  </a:xfrm>
+                  <a:prstGeom prst="rect">
+                    <a:avLst/>
+                  </a:prstGeom>
+                  <a:noFill/>
+                </p:spPr>
+                <p:txBody>
+                  <a:bodyPr wrap="square" rtlCol="0">
+                    <a:spAutoFit/>
+                  </a:bodyPr>
+                  <a:lstStyle/>
+                  <a:p>
+                    <a:r>
+                      <a:rPr lang="en-US" sz="2160" dirty="0"/>
+                      <a:t>Sweethall</a:t>
+                    </a:r>
+                  </a:p>
+                </p:txBody>
+              </p:sp>
+            </p:grpSp>
+          </p:grpSp>
+        </p:grpSp>
+      </p:grpSp>
+      <p:pic>
+        <p:nvPicPr>
+          <p:cNvPr id="30" name="Picture 29" descr="A graph of different colored lines&#10;&#10;AI-generated content may be incorrect.">
+            <a:extLst>
+              <a:ext uri="{FF2B5EF4-FFF2-40B4-BE49-F238E27FC236}">
+                <a16:creationId xmlns:a16="http://schemas.microsoft.com/office/drawing/2014/main" id="{E49A93CD-9A22-A9D8-A4F9-ABBFD8A3A429}"/>
+              </a:ext>
+            </a:extLst>
+          </p:cNvPr>
+          <p:cNvPicPr>
+            <a:picLocks noChangeAspect="1"/>
+          </p:cNvPicPr>
+          <p:nvPr/>
+        </p:nvPicPr>
+        <p:blipFill>
+          <a:blip r:embed="rId5">
+            <a:extLst>
+              <a:ext uri="{28A0092B-C50C-407E-A947-70E740481C1C}">
+                <a14:useLocalDpi xmlns:a14="http://schemas.microsoft.com/office/drawing/2010/main" val="0"/>
+              </a:ext>
+            </a:extLst>
+          </a:blip>
+          <a:srcRect l="88306" t="32174" b="33648"/>
+          <a:stretch>
+            <a:fillRect/>
+          </a:stretch>
+        </p:blipFill>
+        <p:spPr>
+          <a:xfrm>
+            <a:off x="18658734" y="33959528"/>
+            <a:ext cx="2943533" cy="2867912"/>
+          </a:xfrm>
+          <a:prstGeom prst="rect">
+            <a:avLst/>
+          </a:prstGeom>
+        </p:spPr>
+      </p:pic>
+      <p:sp>
+        <p:nvSpPr>
+          <p:cNvPr id="31" name="Text Placeholder 3">
+            <a:extLst>
+              <a:ext uri="{FF2B5EF4-FFF2-40B4-BE49-F238E27FC236}">
+                <a16:creationId xmlns:a16="http://schemas.microsoft.com/office/drawing/2014/main" id="{EBEF1B36-51E3-0CF2-F9CF-8EAE0D3881FF}"/>
+              </a:ext>
+            </a:extLst>
+          </p:cNvPr>
+          <p:cNvSpPr txBox="1">
+            <a:spLocks/>
+          </p:cNvSpPr>
+          <p:nvPr/>
+        </p:nvSpPr>
+        <p:spPr>
+          <a:xfrm>
+            <a:off x="2775359" y="24275641"/>
+            <a:ext cx="15126388" cy="9786036"/>
+          </a:xfrm>
+          <a:prstGeom prst="rect">
+            <a:avLst/>
+          </a:prstGeom>
+          <a:ln>
+            <a:noFill/>
+          </a:ln>
+        </p:spPr>
+        <p:txBody>
+          <a:bodyPr/>
+          <a:lstStyle>
+            <a:lvl1pPr marL="0" indent="0" algn="l" defTabSz="1654622" rtl="0" eaLnBrk="1" latinLnBrk="0" hangingPunct="1">
+              <a:spcBef>
+                <a:spcPct val="20000"/>
+              </a:spcBef>
+              <a:buFont typeface="Arial" pitchFamily="34" charset="0"/>
+              <a:buNone/>
+              <a:defRPr lang="en-US" sz="2850" kern="1200" dirty="0">
+                <a:solidFill>
+                  <a:schemeClr val="tx1"/>
+                </a:solidFill>
+                <a:latin typeface="Arial" panose="020B0604020202020204" pitchFamily="34" charset="0"/>
+                <a:ea typeface="+mn-ea"/>
+                <a:cs typeface="Arial" panose="020B0604020202020204" pitchFamily="34" charset="0"/>
+              </a:defRPr>
+            </a:lvl1pPr>
+            <a:lvl2pPr marL="1344381" indent="-517070" algn="l" defTabSz="1654622" rtl="0" eaLnBrk="1" latinLnBrk="0" hangingPunct="1">
+              <a:spcBef>
+                <a:spcPct val="20000"/>
+              </a:spcBef>
+              <a:buFont typeface="Arial" pitchFamily="34" charset="0"/>
+              <a:buChar char="–"/>
+              <a:defRPr sz="5067" kern="1200">
+                <a:solidFill>
+                  <a:schemeClr val="tx1"/>
+                </a:solidFill>
+                <a:latin typeface="+mn-lt"/>
+                <a:ea typeface="+mn-ea"/>
+                <a:cs typeface="+mn-cs"/>
+              </a:defRPr>
+            </a:lvl2pPr>
+            <a:lvl3pPr marL="2068278" indent="-413656" algn="l" defTabSz="1654622" rtl="0" eaLnBrk="1" latinLnBrk="0" hangingPunct="1">
+              <a:spcBef>
+                <a:spcPct val="20000"/>
+              </a:spcBef>
+              <a:buFont typeface="Arial" pitchFamily="34" charset="0"/>
+              <a:buChar char="•"/>
+              <a:defRPr sz="4328" kern="1200">
+                <a:solidFill>
+                  <a:schemeClr val="tx1"/>
+                </a:solidFill>
+                <a:latin typeface="+mn-lt"/>
+                <a:ea typeface="+mn-ea"/>
+                <a:cs typeface="+mn-cs"/>
+              </a:defRPr>
+            </a:lvl3pPr>
+            <a:lvl4pPr marL="2895590" indent="-413656" algn="l" defTabSz="1654622" rtl="0" eaLnBrk="1" latinLnBrk="0" hangingPunct="1">
+              <a:spcBef>
+                <a:spcPct val="20000"/>
+              </a:spcBef>
+              <a:buFont typeface="Arial" pitchFamily="34" charset="0"/>
+              <a:buChar char="–"/>
+              <a:defRPr sz="3695" kern="1200">
+                <a:solidFill>
+                  <a:schemeClr val="tx1"/>
+                </a:solidFill>
+                <a:latin typeface="+mn-lt"/>
+                <a:ea typeface="+mn-ea"/>
+                <a:cs typeface="+mn-cs"/>
+              </a:defRPr>
+            </a:lvl4pPr>
+            <a:lvl5pPr marL="3722900" indent="-413656" algn="l" defTabSz="1654622" rtl="0" eaLnBrk="1" latinLnBrk="0" hangingPunct="1">
+              <a:spcBef>
+                <a:spcPct val="20000"/>
+              </a:spcBef>
+              <a:buFont typeface="Arial" pitchFamily="34" charset="0"/>
+              <a:buChar char="»"/>
+              <a:defRPr sz="3695" kern="1200">
+                <a:solidFill>
+                  <a:schemeClr val="tx1"/>
+                </a:solidFill>
+                <a:latin typeface="+mn-lt"/>
+                <a:ea typeface="+mn-ea"/>
+                <a:cs typeface="+mn-cs"/>
+              </a:defRPr>
+            </a:lvl5pPr>
+            <a:lvl6pPr marL="4550212" indent="-413656" algn="l" defTabSz="1654622" rtl="0" eaLnBrk="1" latinLnBrk="0" hangingPunct="1">
+              <a:spcBef>
+                <a:spcPct val="20000"/>
+              </a:spcBef>
+              <a:buFont typeface="Arial" pitchFamily="34" charset="0"/>
+              <a:buChar char="•"/>
+              <a:defRPr sz="3695" kern="1200">
+                <a:solidFill>
+                  <a:schemeClr val="tx1"/>
+                </a:solidFill>
+                <a:latin typeface="+mn-lt"/>
+                <a:ea typeface="+mn-ea"/>
+                <a:cs typeface="+mn-cs"/>
+              </a:defRPr>
+            </a:lvl6pPr>
+            <a:lvl7pPr marL="5377522" indent="-413656" algn="l" defTabSz="1654622" rtl="0" eaLnBrk="1" latinLnBrk="0" hangingPunct="1">
+              <a:spcBef>
+                <a:spcPct val="20000"/>
+              </a:spcBef>
+              <a:buFont typeface="Arial" pitchFamily="34" charset="0"/>
+              <a:buChar char="•"/>
+              <a:defRPr sz="3695" kern="1200">
+                <a:solidFill>
+                  <a:schemeClr val="tx1"/>
+                </a:solidFill>
+                <a:latin typeface="+mn-lt"/>
+                <a:ea typeface="+mn-ea"/>
+                <a:cs typeface="+mn-cs"/>
+              </a:defRPr>
+            </a:lvl7pPr>
+            <a:lvl8pPr marL="6204835" indent="-413656" algn="l" defTabSz="1654622" rtl="0" eaLnBrk="1" latinLnBrk="0" hangingPunct="1">
+              <a:spcBef>
+                <a:spcPct val="20000"/>
+              </a:spcBef>
+              <a:buFont typeface="Arial" pitchFamily="34" charset="0"/>
+              <a:buChar char="•"/>
+              <a:defRPr sz="3695" kern="1200">
+                <a:solidFill>
+                  <a:schemeClr val="tx1"/>
+                </a:solidFill>
+                <a:latin typeface="+mn-lt"/>
+                <a:ea typeface="+mn-ea"/>
+                <a:cs typeface="+mn-cs"/>
+              </a:defRPr>
+            </a:lvl8pPr>
+            <a:lvl9pPr marL="7032146" indent="-413656" algn="l" defTabSz="1654622" rtl="0" eaLnBrk="1" latinLnBrk="0" hangingPunct="1">
+              <a:spcBef>
+                <a:spcPct val="20000"/>
+              </a:spcBef>
+              <a:buFont typeface="Arial" pitchFamily="34" charset="0"/>
+              <a:buChar char="•"/>
+              <a:defRPr sz="3695" kern="1200">
+                <a:solidFill>
+                  <a:schemeClr val="tx1"/>
+                </a:solidFill>
+                <a:latin typeface="+mn-lt"/>
+                <a:ea typeface="+mn-ea"/>
+                <a:cs typeface="+mn-cs"/>
+              </a:defRPr>
+            </a:lvl9pPr>
+          </a:lstStyle>
+          <a:p>
+            <a:r>
+              <a:rPr lang="en-US" sz="4320" b="1" dirty="0">
+                <a:solidFill>
+                  <a:srgbClr val="75BFE2"/>
+                </a:solidFill>
+              </a:rPr>
+              <a:t>Porewater Sulfate</a:t>
+            </a:r>
+          </a:p>
+          <a:p>
+            <a:pPr marL="548640" indent="-548640">
+              <a:buFont typeface="Arial" panose="020B0604020202020204" pitchFamily="34" charset="0"/>
+              <a:buChar char="•"/>
+            </a:pPr>
+            <a:r>
+              <a:rPr lang="en-US" sz="3360" dirty="0"/>
+              <a:t>Porewater was analyzed for </a:t>
+            </a:r>
+            <a:r>
+              <a:rPr lang="en-US" sz="3360" b="1" dirty="0"/>
+              <a:t>SO</a:t>
+            </a:r>
+            <a:r>
+              <a:rPr lang="en-US" sz="3360" b="1" baseline="-25000" dirty="0"/>
+              <a:t>4</a:t>
+            </a:r>
+            <a:r>
+              <a:rPr lang="en-US" sz="3360" b="1" baseline="30000" dirty="0"/>
+              <a:t>2-</a:t>
+            </a:r>
+            <a:r>
+              <a:rPr lang="en-US" sz="3360" dirty="0"/>
+              <a:t> in 2,293 samples</a:t>
+            </a:r>
+          </a:p>
+          <a:p>
+            <a:pPr marL="548640" indent="-548640">
+              <a:buFont typeface="Arial" panose="020B0604020202020204" pitchFamily="34" charset="0"/>
+              <a:buChar char="•"/>
+            </a:pPr>
+            <a:r>
+              <a:rPr lang="en-US" sz="3360" dirty="0"/>
+              <a:t>Sulfate increased from upland forest through transition zones to the wetland</a:t>
+            </a:r>
+          </a:p>
+          <a:p>
+            <a:pPr marL="548640" indent="-548640">
+              <a:buFont typeface="Arial" panose="020B0604020202020204" pitchFamily="34" charset="0"/>
+              <a:buChar char="•"/>
+            </a:pPr>
+            <a:r>
+              <a:rPr lang="en-US" sz="3360" dirty="0"/>
+              <a:t>Sulfate also increased from </a:t>
+            </a:r>
+            <a:r>
+              <a:rPr lang="en-US" sz="3360" dirty="0" err="1"/>
+              <a:t>Sweethall</a:t>
+            </a:r>
+            <a:r>
+              <a:rPr lang="en-US" sz="3360" dirty="0"/>
+              <a:t> site (oligohaline) to Goodwin Islands site (</a:t>
+            </a:r>
+            <a:r>
+              <a:rPr lang="en-US" sz="3360" dirty="0" err="1"/>
+              <a:t>polyhaline</a:t>
+            </a:r>
+            <a:r>
+              <a:rPr lang="en-US" sz="3360" dirty="0"/>
+              <a:t>). </a:t>
+            </a:r>
+          </a:p>
+          <a:p>
+            <a:pPr marL="548640" indent="-548640">
+              <a:buFont typeface="Arial" panose="020B0604020202020204" pitchFamily="34" charset="0"/>
+              <a:buChar char="•"/>
+            </a:pPr>
+            <a:r>
+              <a:rPr lang="en-US" sz="3360" dirty="0"/>
+              <a:t>Surface water was a source of sulfate into these ecosystems. </a:t>
+            </a:r>
+          </a:p>
+          <a:p>
+            <a:pPr marL="548640" indent="-548640">
+              <a:buFont typeface="Arial" panose="020B0604020202020204" pitchFamily="34" charset="0"/>
+              <a:buChar char="•"/>
+            </a:pPr>
+            <a:endParaRPr lang="en-US" sz="3840" dirty="0"/>
+          </a:p>
+          <a:p>
+            <a:pPr marL="548640" indent="-548640">
+              <a:buFont typeface="Arial" panose="020B0604020202020204" pitchFamily="34" charset="0"/>
+              <a:buChar char="•"/>
+            </a:pPr>
+            <a:endParaRPr lang="en-US" sz="3420" dirty="0"/>
+          </a:p>
+        </p:txBody>
+      </p:sp>
+      <p:pic>
+        <p:nvPicPr>
+          <p:cNvPr id="32" name="Picture 31" descr="A graph of different colored squares&#10;&#10;AI-generated content may be incorrect.">
+            <a:extLst>
+              <a:ext uri="{FF2B5EF4-FFF2-40B4-BE49-F238E27FC236}">
+                <a16:creationId xmlns:a16="http://schemas.microsoft.com/office/drawing/2014/main" id="{98B7A699-3802-B555-5777-71C8B25EFD4A}"/>
+              </a:ext>
+            </a:extLst>
+          </p:cNvPr>
+          <p:cNvPicPr>
+            <a:picLocks noChangeAspect="1"/>
+          </p:cNvPicPr>
+          <p:nvPr/>
+        </p:nvPicPr>
+        <p:blipFill>
+          <a:blip r:embed="rId6">
+            <a:extLst>
+              <a:ext uri="{28A0092B-C50C-407E-A947-70E740481C1C}">
+                <a14:useLocalDpi xmlns:a14="http://schemas.microsoft.com/office/drawing/2010/main" val="0"/>
+              </a:ext>
+            </a:extLst>
+          </a:blip>
+          <a:srcRect t="4399"/>
+          <a:stretch>
+            <a:fillRect/>
+          </a:stretch>
+        </p:blipFill>
+        <p:spPr>
+          <a:xfrm>
+            <a:off x="3024515" y="28483504"/>
+            <a:ext cx="13849991" cy="7944434"/>
+          </a:xfrm>
+          <a:prstGeom prst="rect">
+            <a:avLst/>
+          </a:prstGeom>
+        </p:spPr>
+      </p:pic>
     </p:spTree>
     <p:extLst>
       <p:ext uri="{BB962C8B-B14F-4D97-AF65-F5344CB8AC3E}">

</xml_diff>